<commit_message>
Slides: merge the two setup slides, 10 -> 9
Requested 'under 10 slides'. Representation and architecture both covered
'how the board becomes something a network can consume', so they combine
into one slide without losing content. With the author's own title slide
the presentation is 10 in total.

Verified by exporting to PDF and inspecting: the three stat panels stack
into one continuous block and clear the footer note.

Co-Authored-By: Claude Opus 5 <noreply@anthropic.com>
</commit_message>
<xml_diff>
--- a/docs/chess_ai_slides.pptx
+++ b/docs/chess_ai_slides.pptx
@@ -14,7 +14,6 @@
     <p:sldId id="262" r:id="rId13"/>
     <p:sldId id="263" r:id="rId14"/>
     <p:sldId id="264" r:id="rId15"/>
-    <p:sldId id="265" r:id="rId16"/>
   </p:sldIdLst>
   <p:sldSz cx="12191695" cy="6858000" type="screen4x3"/>
   <p:notesSz cx="6858000" cy="9144000"/>
@@ -3588,512 +3587,6 @@
 </p:sld>
 </file>
 
-<file path=ppt/slides/slide10.xml><?xml version="1.0" encoding="utf-8"?>
-<p:sld xmlns:a="http://schemas.openxmlformats.org/drawingml/2006/main" xmlns:p="http://schemas.openxmlformats.org/presentationml/2006/main" xmlns:r="http://schemas.openxmlformats.org/officeDocument/2006/relationships">
-  <p:cSld>
-    <p:bg>
-      <p:bgPr>
-        <a:solidFill>
-          <a:srgbClr val="FFFFFF"/>
-        </a:solidFill>
-        <a:effectLst/>
-      </p:bgPr>
-    </p:bg>
-    <p:spTree>
-      <p:nvGrpSpPr>
-        <p:cNvPr id="1" name=""/>
-        <p:cNvGrpSpPr/>
-        <p:nvPr/>
-      </p:nvGrpSpPr>
-      <p:grpSpPr/>
-      <p:sp>
-        <p:nvSpPr>
-          <p:cNvPr id="2" name="TextBox 1"/>
-          <p:cNvSpPr txBox="1"/>
-          <p:nvPr/>
-        </p:nvSpPr>
-        <p:spPr>
-          <a:xfrm>
-            <a:off x="685800" y="411480"/>
-            <a:ext cx="10820095" cy="1234440"/>
-          </a:xfrm>
-          <a:prstGeom prst="rect">
-            <a:avLst/>
-          </a:prstGeom>
-          <a:noFill/>
-        </p:spPr>
-        <p:txBody>
-          <a:bodyPr wrap="square">
-            <a:spAutoFit/>
-          </a:bodyPr>
-          <a:lstStyle/>
-          <a:p>
-            <a:pPr algn="l">
-              <a:spcBef>
-                <a:spcPts val="0"/>
-              </a:spcBef>
-              <a:spcAft>
-                <a:spcPts val="400"/>
-              </a:spcAft>
-            </a:pPr>
-            <a:r>
-              <a:rPr sz="1300" b="1" i="0">
-                <a:solidFill>
-                  <a:srgbClr val="1F4E9C"/>
-                </a:solidFill>
-                <a:latin typeface="Segoe UI"/>
-              </a:rPr>
-              <a:t>WHAT I TAKE AWAY</a:t>
-            </a:r>
-          </a:p>
-          <a:p>
-            <a:pPr algn="l">
-              <a:spcBef>
-                <a:spcPts val="0"/>
-              </a:spcBef>
-              <a:spcAft>
-                <a:spcPts val="0"/>
-              </a:spcAft>
-            </a:pPr>
-            <a:r>
-              <a:rPr sz="3300" b="1" i="0">
-                <a:solidFill>
-                  <a:srgbClr val="1A1D24"/>
-                </a:solidFill>
-                <a:latin typeface="Segoe UI"/>
-              </a:rPr>
-              <a:t>Measurement is the hard part</a:t>
-            </a:r>
-          </a:p>
-        </p:txBody>
-      </p:sp>
-      <p:sp>
-        <p:nvSpPr>
-          <p:cNvPr id="3" name="Rectangle 2"/>
-          <p:cNvSpPr/>
-          <p:nvPr/>
-        </p:nvSpPr>
-        <p:spPr>
-          <a:xfrm>
-            <a:off x="685800" y="1572768"/>
-            <a:ext cx="1371600" cy="38100"/>
-          </a:xfrm>
-          <a:prstGeom prst="rect">
-            <a:avLst/>
-          </a:prstGeom>
-          <a:solidFill>
-            <a:srgbClr val="1F4E9C"/>
-          </a:solidFill>
-          <a:ln>
-            <a:noFill/>
-          </a:ln>
-          <a:effectLst/>
-        </p:spPr>
-        <p:style>
-          <a:lnRef idx="1">
-            <a:schemeClr val="accent1"/>
-          </a:lnRef>
-          <a:fillRef idx="3">
-            <a:schemeClr val="accent1"/>
-          </a:fillRef>
-          <a:effectRef idx="2">
-            <a:schemeClr val="accent1"/>
-          </a:effectRef>
-          <a:fontRef idx="minor">
-            <a:schemeClr val="lt1"/>
-          </a:fontRef>
-        </p:style>
-        <p:txBody>
-          <a:bodyPr rtlCol="0" anchor="ctr"/>
-          <a:lstStyle/>
-          <a:p>
-            <a:pPr algn="ctr"/>
-          </a:p>
-        </p:txBody>
-      </p:sp>
-      <p:sp>
-        <p:nvSpPr>
-          <p:cNvPr id="4" name="TextBox 3"/>
-          <p:cNvSpPr txBox="1"/>
-          <p:nvPr/>
-        </p:nvSpPr>
-        <p:spPr>
-          <a:xfrm>
-            <a:off x="685800" y="1874519"/>
-            <a:ext cx="6949440" cy="4434841"/>
-          </a:xfrm>
-          <a:prstGeom prst="rect">
-            <a:avLst/>
-          </a:prstGeom>
-          <a:noFill/>
-        </p:spPr>
-        <p:txBody>
-          <a:bodyPr wrap="square">
-            <a:spAutoFit/>
-          </a:bodyPr>
-          <a:lstStyle/>
-          <a:p>
-            <a:pPr algn="l">
-              <a:spcBef>
-                <a:spcPts val="0"/>
-              </a:spcBef>
-              <a:spcAft>
-                <a:spcPts val="1300"/>
-              </a:spcAft>
-            </a:pPr>
-            <a:r>
-              <a:rPr sz="1600" b="1" i="0">
-                <a:solidFill>
-                  <a:srgbClr val="1A1D24"/>
-                </a:solidFill>
-                <a:latin typeface="Segoe UI"/>
-              </a:rPr>
-              <a:t>A falling loss curve is not evidence that anything is working.</a:t>
-            </a:r>
-          </a:p>
-          <a:p>
-            <a:pPr algn="l">
-              <a:spcBef>
-                <a:spcPts val="0"/>
-              </a:spcBef>
-              <a:spcAft>
-                <a:spcPts val="1300"/>
-              </a:spcAft>
-            </a:pPr>
-            <a:r>
-              <a:rPr sz="1600" b="0" i="0">
-                <a:solidFill>
-                  <a:srgbClr val="1A1D24"/>
-                </a:solidFill>
-                <a:latin typeface="Segoe UI"/>
-              </a:rPr>
-              <a:t>Especially when the model produces its own labels.</a:t>
-            </a:r>
-          </a:p>
-          <a:p>
-            <a:pPr algn="l">
-              <a:spcBef>
-                <a:spcPts val="0"/>
-              </a:spcBef>
-              <a:spcAft>
-                <a:spcPts val="1300"/>
-              </a:spcAft>
-            </a:pPr>
-            <a:r>
-              <a:rPr sz="1600" b="1" i="0">
-                <a:solidFill>
-                  <a:srgbClr val="1A1D24"/>
-                </a:solidFill>
-                <a:latin typeface="Segoe UI"/>
-              </a:rPr>
-              <a:t>Verify the metric before trusting the model.</a:t>
-            </a:r>
-          </a:p>
-          <a:p>
-            <a:pPr algn="l">
-              <a:spcBef>
-                <a:spcPts val="0"/>
-              </a:spcBef>
-              <a:spcAft>
-                <a:spcPts val="1300"/>
-              </a:spcAft>
-            </a:pPr>
-            <a:r>
-              <a:rPr sz="1600" b="0" i="0">
-                <a:solidFill>
-                  <a:srgbClr val="1A1D24"/>
-                </a:solidFill>
-                <a:latin typeface="Segoe UI"/>
-              </a:rPr>
-              <a:t>Mine returned a plausible number 159 times in a row while measuring nothing at all.</a:t>
-            </a:r>
-          </a:p>
-          <a:p>
-            <a:pPr algn="l">
-              <a:spcBef>
-                <a:spcPts val="0"/>
-              </a:spcBef>
-              <a:spcAft>
-                <a:spcPts val="1300"/>
-              </a:spcAft>
-            </a:pPr>
-            <a:r>
-              <a:rPr sz="1600" b="1" i="0">
-                <a:solidFill>
-                  <a:srgbClr val="1A1D24"/>
-                </a:solidFill>
-                <a:latin typeface="Segoe UI"/>
-              </a:rPr>
-              <a:t>Downscaling changes which statistic matters.</a:t>
-            </a:r>
-          </a:p>
-          <a:p>
-            <a:pPr algn="l">
-              <a:spcBef>
-                <a:spcPts val="0"/>
-              </a:spcBef>
-              <a:spcAft>
-                <a:spcPts val="1300"/>
-              </a:spcAft>
-            </a:pPr>
-            <a:r>
-              <a:rPr sz="1600" b="0" i="0">
-                <a:solidFill>
-                  <a:srgbClr val="1A1D24"/>
-                </a:solidFill>
-                <a:latin typeface="Segoe UI"/>
-              </a:rPr>
-              <a:t>800 → 40 simulations preserves the best move but destroys the distribution — and the loss reads the distribution.</a:t>
-            </a:r>
-          </a:p>
-          <a:p>
-            <a:pPr algn="l">
-              <a:spcBef>
-                <a:spcPts val="0"/>
-              </a:spcBef>
-              <a:spcAft>
-                <a:spcPts val="1300"/>
-              </a:spcAft>
-            </a:pPr>
-            <a:r>
-              <a:rPr sz="1600" b="1" i="0">
-                <a:solidFill>
-                  <a:srgbClr val="B3352C"/>
-                </a:solidFill>
-                <a:latin typeface="Segoe UI"/>
-              </a:rPr>
-              <a:t>Then audit the fix too.</a:t>
-            </a:r>
-          </a:p>
-          <a:p>
-            <a:pPr algn="l">
-              <a:spcBef>
-                <a:spcPts val="0"/>
-              </a:spcBef>
-              <a:spcAft>
-                <a:spcPts val="1300"/>
-              </a:spcAft>
-            </a:pPr>
-            <a:r>
-              <a:rPr sz="1600" b="0" i="0">
-                <a:solidFill>
-                  <a:srgbClr val="1A1D24"/>
-                </a:solidFill>
-                <a:latin typeface="Segoe UI"/>
-              </a:rPr>
-              <a:t>My gate promoted 8 of 20 candidates. Pure chance predicts 7.8 — an 8-game match could never have resolved this. The same mistake, one level up.</a:t>
-            </a:r>
-          </a:p>
-        </p:txBody>
-      </p:sp>
-      <p:sp>
-        <p:nvSpPr>
-          <p:cNvPr id="5" name="Rectangle 4"/>
-          <p:cNvSpPr/>
-          <p:nvPr/>
-        </p:nvSpPr>
-        <p:spPr>
-          <a:xfrm>
-            <a:off x="8138160" y="2103120"/>
-            <a:ext cx="3291840" cy="3108960"/>
-          </a:xfrm>
-          <a:prstGeom prst="rect">
-            <a:avLst/>
-          </a:prstGeom>
-          <a:solidFill>
-            <a:srgbClr val="F2F5F9"/>
-          </a:solidFill>
-          <a:ln>
-            <a:noFill/>
-          </a:ln>
-          <a:effectLst/>
-        </p:spPr>
-        <p:style>
-          <a:lnRef idx="1">
-            <a:schemeClr val="accent1"/>
-          </a:lnRef>
-          <a:fillRef idx="3">
-            <a:schemeClr val="accent1"/>
-          </a:fillRef>
-          <a:effectRef idx="2">
-            <a:schemeClr val="accent1"/>
-          </a:effectRef>
-          <a:fontRef idx="minor">
-            <a:schemeClr val="lt1"/>
-          </a:fontRef>
-        </p:style>
-        <p:txBody>
-          <a:bodyPr rtlCol="0" anchor="ctr"/>
-          <a:lstStyle/>
-          <a:p>
-            <a:pPr algn="ctr"/>
-          </a:p>
-        </p:txBody>
-      </p:sp>
-      <p:sp>
-        <p:nvSpPr>
-          <p:cNvPr id="6" name="TextBox 5"/>
-          <p:cNvSpPr txBox="1"/>
-          <p:nvPr/>
-        </p:nvSpPr>
-        <p:spPr>
-          <a:xfrm>
-            <a:off x="8366760" y="2331720"/>
-            <a:ext cx="2834640" cy="2743200"/>
-          </a:xfrm>
-          <a:prstGeom prst="rect">
-            <a:avLst/>
-          </a:prstGeom>
-          <a:noFill/>
-        </p:spPr>
-        <p:txBody>
-          <a:bodyPr wrap="square">
-            <a:spAutoFit/>
-          </a:bodyPr>
-          <a:lstStyle/>
-          <a:p>
-            <a:pPr algn="l">
-              <a:spcBef>
-                <a:spcPts val="0"/>
-              </a:spcBef>
-              <a:spcAft>
-                <a:spcPts val="1200"/>
-              </a:spcAft>
-            </a:pPr>
-            <a:r>
-              <a:rPr sz="1700" b="1" i="0">
-                <a:solidFill>
-                  <a:srgbClr val="1F4E9C"/>
-                </a:solidFill>
-                <a:latin typeface="Segoe UI"/>
-              </a:rPr>
-              <a:t>Artifacts</a:t>
-            </a:r>
-          </a:p>
-          <a:p>
-            <a:pPr algn="l">
-              <a:spcBef>
-                <a:spcPts val="0"/>
-              </a:spcBef>
-              <a:spcAft>
-                <a:spcPts val="200"/>
-              </a:spcAft>
-            </a:pPr>
-            <a:r>
-              <a:rPr sz="1300" b="1" i="0">
-                <a:solidFill>
-                  <a:srgbClr val="5A6472"/>
-                </a:solidFill>
-                <a:latin typeface="Segoe UI"/>
-              </a:rPr>
-              <a:t>Code</a:t>
-            </a:r>
-          </a:p>
-          <a:p>
-            <a:pPr algn="l">
-              <a:spcBef>
-                <a:spcPts val="0"/>
-              </a:spcBef>
-              <a:spcAft>
-                <a:spcPts val="1200"/>
-              </a:spcAft>
-            </a:pPr>
-            <a:r>
-              <a:rPr sz="1200" b="0" i="0">
-                <a:solidFill>
-                  <a:srgbClr val="1A1D24"/>
-                </a:solidFill>
-                <a:latin typeface="Segoe UI"/>
-              </a:rPr>
-              <a:t>github.com/realgauravvyas/chess-ai</a:t>
-            </a:r>
-          </a:p>
-          <a:p>
-            <a:pPr algn="l">
-              <a:spcBef>
-                <a:spcPts val="0"/>
-              </a:spcBef>
-              <a:spcAft>
-                <a:spcPts val="200"/>
-              </a:spcAft>
-            </a:pPr>
-            <a:r>
-              <a:rPr sz="1300" b="1" i="0">
-                <a:solidFill>
-                  <a:srgbClr val="5A6472"/>
-                </a:solidFill>
-                <a:latin typeface="Segoe UI"/>
-              </a:rPr>
-              <a:t>Results</a:t>
-            </a:r>
-          </a:p>
-          <a:p>
-            <a:pPr algn="l">
-              <a:spcBef>
-                <a:spcPts val="0"/>
-              </a:spcBef>
-              <a:spcAft>
-                <a:spcPts val="1200"/>
-              </a:spcAft>
-            </a:pPr>
-            <a:r>
-              <a:rPr sz="1200" b="0" i="0">
-                <a:solidFill>
-                  <a:srgbClr val="1A1D24"/>
-                </a:solidFill>
-                <a:latin typeface="Segoe UI"/>
-              </a:rPr>
-              <a:t>RESULTS.md — every number, reproducible</a:t>
-            </a:r>
-          </a:p>
-          <a:p>
-            <a:pPr algn="l">
-              <a:spcBef>
-                <a:spcPts val="0"/>
-              </a:spcBef>
-              <a:spcAft>
-                <a:spcPts val="200"/>
-              </a:spcAft>
-            </a:pPr>
-            <a:r>
-              <a:rPr sz="1300" b="1" i="0">
-                <a:solidFill>
-                  <a:srgbClr val="5A6472"/>
-                </a:solidFill>
-                <a:latin typeface="Segoe UI"/>
-              </a:rPr>
-              <a:t>Demo</a:t>
-            </a:r>
-          </a:p>
-          <a:p>
-            <a:pPr algn="l">
-              <a:spcBef>
-                <a:spcPts val="0"/>
-              </a:spcBef>
-              <a:spcAft>
-                <a:spcPts val="0"/>
-              </a:spcAft>
-            </a:pPr>
-            <a:r>
-              <a:rPr sz="1200" b="0" i="0">
-                <a:solidFill>
-                  <a:srgbClr val="1A1D24"/>
-                </a:solidFill>
-                <a:latin typeface="Segoe UI"/>
-              </a:rPr>
-              <a:t>Live training dashboard + play any checkpoint</a:t>
-            </a:r>
-          </a:p>
-        </p:txBody>
-      </p:sp>
-    </p:spTree>
-  </p:cSld>
-  <p:clrMapOvr>
-    <a:masterClrMapping/>
-  </p:clrMapOvr>
-</p:sld>
-</file>
-
 <file path=ppt/slides/slide2.xml><?xml version="1.0" encoding="utf-8"?>
 <p:sld xmlns:a="http://schemas.openxmlformats.org/drawingml/2006/main" xmlns:p="http://schemas.openxmlformats.org/presentationml/2006/main" xmlns:r="http://schemas.openxmlformats.org/officeDocument/2006/relationships">
   <p:cSld>
@@ -4168,7 +3661,7 @@
                 </a:solidFill>
                 <a:latin typeface="Segoe UI"/>
               </a:rPr>
-              <a:t>Turning a chessboard into a tensor</a:t>
+              <a:t>From chessboard to tensor to network</a:t>
             </a:r>
           </a:p>
         </p:txBody>
@@ -4225,8 +3718,8 @@
         </p:nvSpPr>
         <p:spPr>
           <a:xfrm>
-            <a:off x="685800" y="1920240"/>
-            <a:ext cx="6858000" cy="4389120"/>
+            <a:off x="685800" y="1874519"/>
+            <a:ext cx="6949440" cy="4434841"/>
           </a:xfrm>
           <a:prstGeom prst="rect">
             <a:avLst/>
@@ -4248,7 +3741,7 @@
               </a:spcAft>
             </a:pPr>
             <a:r>
-              <a:rPr sz="1800" b="1" i="0">
+              <a:rPr sz="1600" b="1" i="0">
                 <a:solidFill>
                   <a:srgbClr val="1F4E9C"/>
                 </a:solidFill>
@@ -4267,13 +3760,13 @@
               </a:spcAft>
             </a:pPr>
             <a:r>
-              <a:rPr sz="1800" b="0" i="0">
+              <a:rPr sz="1600" b="0" i="0">
                 <a:solidFill>
                   <a:srgbClr val="1A1D24"/>
                 </a:solidFill>
                 <a:latin typeface="Segoe UI"/>
               </a:rPr>
-              <a:t>12 piece planes (6 types × 2 colours)  ·  4 castling rights  ·  1 en passant  ·  1 side to move</a:t>
+              <a:t>12 piece planes (6 types × 2 colours) · 4 castling rights · 1 en passant · 1 side to move</a:t>
             </a:r>
           </a:p>
           <a:p>
@@ -4286,7 +3779,7 @@
               </a:spcAft>
             </a:pPr>
             <a:r>
-              <a:rPr sz="1800" b="1" i="0">
+              <a:rPr sz="1600" b="1" i="0">
                 <a:solidFill>
                   <a:srgbClr val="1F4E9C"/>
                 </a:solidFill>
@@ -4305,13 +3798,13 @@
               </a:spcAft>
             </a:pPr>
             <a:r>
-              <a:rPr sz="1800" b="0" i="0">
+              <a:rPr sz="1600" b="0" i="0">
                 <a:solidFill>
                   <a:srgbClr val="1A1D24"/>
                 </a:solidFill>
                 <a:latin typeface="Segoe UI"/>
               </a:rPr>
-              <a:t>64 origin squares × 73 move types: 56 queen-style, 8 knight, 9 underpromotions.</a:t>
+              <a:t>64 origin squares × 73 move types: 56 queen-style, 8 knight, 9 underpromotions. Every legal move maps to exactly one index — round-trip tested, 0 collisions.</a:t>
             </a:r>
           </a:p>
           <a:p>
@@ -4324,13 +3817,51 @@
               </a:spcAft>
             </a:pPr>
             <a:r>
-              <a:rPr sz="1800" b="0" i="0">
+              <a:rPr sz="1600" b="1" i="0">
+                <a:solidFill>
+                  <a:srgbClr val="1F4E9C"/>
+                </a:solidFill>
+                <a:latin typeface="Segoe UI"/>
+              </a:rPr>
+              <a:t>The network</a:t>
+            </a:r>
+          </a:p>
+          <a:p>
+            <a:pPr algn="l">
+              <a:spcBef>
+                <a:spcPts val="0"/>
+              </a:spcBef>
+              <a:spcAft>
+                <a:spcPts val="1300"/>
+              </a:spcAft>
+            </a:pPr>
+            <a:r>
+              <a:rPr sz="1600" b="0" i="0">
                 <a:solidFill>
                   <a:srgbClr val="1A1D24"/>
                 </a:solidFill>
                 <a:latin typeface="Segoe UI"/>
               </a:rPr>
-              <a:t>Every legal chess move maps to exactly one index. Verified by a round-trip test over thousands of positions: 0 collisions.</a:t>
+              <a:t>3×3 conv 18→64, ten residual blocks with batch norm, then two heads: policy → 4,672 logits, value → one scalar in [−1, 1].</a:t>
+            </a:r>
+          </a:p>
+          <a:p>
+            <a:pPr algn="l">
+              <a:spcBef>
+                <a:spcPts val="0"/>
+              </a:spcBef>
+              <a:spcAft>
+                <a:spcPts val="1300"/>
+              </a:spcAft>
+            </a:pPr>
+            <a:r>
+              <a:rPr sz="1600" b="0" i="0">
+                <a:solidFill>
+                  <a:srgbClr val="1A1D24"/>
+                </a:solidFill>
+                <a:latin typeface="Segoe UI"/>
+              </a:rPr>
+              <a:t>Both heads share the trunk, so one representation must serve two tasks.</a:t>
             </a:r>
           </a:p>
         </p:txBody>
@@ -4343,7 +3874,7 @@
         </p:nvSpPr>
         <p:spPr>
           <a:xfrm>
-            <a:off x="8046720" y="2194560"/>
+            <a:off x="8046720" y="2011680"/>
             <a:ext cx="3383280" cy="1508760"/>
           </a:xfrm>
           <a:prstGeom prst="rect">
@@ -4387,7 +3918,7 @@
         </p:nvSpPr>
         <p:spPr>
           <a:xfrm>
-            <a:off x="8046720" y="2359152"/>
+            <a:off x="8046720" y="2176272"/>
             <a:ext cx="3383280" cy="1188720"/>
           </a:xfrm>
           <a:prstGeom prst="rect">
@@ -4410,7 +3941,7 @@
               </a:spcAft>
             </a:pPr>
             <a:r>
-              <a:rPr sz="3600" b="1" i="0">
+              <a:rPr sz="3200" b="1" i="0">
                 <a:solidFill>
                   <a:srgbClr val="1F4E9C"/>
                 </a:solidFill>
@@ -4448,7 +3979,7 @@
         </p:nvSpPr>
         <p:spPr>
           <a:xfrm>
-            <a:off x="8046720" y="3886200"/>
+            <a:off x="8046720" y="3520440"/>
             <a:ext cx="3383280" cy="1508760"/>
           </a:xfrm>
           <a:prstGeom prst="rect">
@@ -4492,7 +4023,7 @@
         </p:nvSpPr>
         <p:spPr>
           <a:xfrm>
-            <a:off x="8046720" y="4050792"/>
+            <a:off x="8046720" y="3685032"/>
             <a:ext cx="3383280" cy="1188720"/>
           </a:xfrm>
           <a:prstGeom prst="rect">
@@ -4515,7 +4046,7 @@
               </a:spcAft>
             </a:pPr>
             <a:r>
-              <a:rPr sz="3600" b="1" i="0">
+              <a:rPr sz="3200" b="1" i="0">
                 <a:solidFill>
                   <a:srgbClr val="1F4E9C"/>
                 </a:solidFill>
@@ -4547,7 +4078,112 @@
       </p:sp>
       <p:sp>
         <p:nvSpPr>
-          <p:cNvPr id="9" name="TextBox 8"/>
+          <p:cNvPr id="9" name="Rectangle 8"/>
+          <p:cNvSpPr/>
+          <p:nvPr/>
+        </p:nvSpPr>
+        <p:spPr>
+          <a:xfrm>
+            <a:off x="8046720" y="5029200"/>
+            <a:ext cx="3383280" cy="1508760"/>
+          </a:xfrm>
+          <a:prstGeom prst="rect">
+            <a:avLst/>
+          </a:prstGeom>
+          <a:solidFill>
+            <a:srgbClr val="F2F5F9"/>
+          </a:solidFill>
+          <a:ln>
+            <a:noFill/>
+          </a:ln>
+          <a:effectLst/>
+        </p:spPr>
+        <p:style>
+          <a:lnRef idx="1">
+            <a:schemeClr val="accent1"/>
+          </a:lnRef>
+          <a:fillRef idx="3">
+            <a:schemeClr val="accent1"/>
+          </a:fillRef>
+          <a:effectRef idx="2">
+            <a:schemeClr val="accent1"/>
+          </a:effectRef>
+          <a:fontRef idx="minor">
+            <a:schemeClr val="lt1"/>
+          </a:fontRef>
+        </p:style>
+        <p:txBody>
+          <a:bodyPr rtlCol="0" anchor="ctr"/>
+          <a:lstStyle/>
+          <a:p>
+            <a:pPr algn="ctr"/>
+          </a:p>
+        </p:txBody>
+      </p:sp>
+      <p:sp>
+        <p:nvSpPr>
+          <p:cNvPr id="10" name="TextBox 9"/>
+          <p:cNvSpPr txBox="1"/>
+          <p:nvPr/>
+        </p:nvSpPr>
+        <p:spPr>
+          <a:xfrm>
+            <a:off x="8046720" y="5193792"/>
+            <a:ext cx="3383280" cy="1188720"/>
+          </a:xfrm>
+          <a:prstGeom prst="rect">
+            <a:avLst/>
+          </a:prstGeom>
+          <a:noFill/>
+        </p:spPr>
+        <p:txBody>
+          <a:bodyPr wrap="square">
+            <a:spAutoFit/>
+          </a:bodyPr>
+          <a:lstStyle/>
+          <a:p>
+            <a:pPr algn="ctr">
+              <a:spcBef>
+                <a:spcPts val="0"/>
+              </a:spcBef>
+              <a:spcAft>
+                <a:spcPts val="200"/>
+              </a:spcAft>
+            </a:pPr>
+            <a:r>
+              <a:rPr sz="3200" b="1" i="0">
+                <a:solidFill>
+                  <a:srgbClr val="1A7F4B"/>
+                </a:solidFill>
+                <a:latin typeface="Segoe UI"/>
+              </a:rPr>
+              <a:t>760,717</a:t>
+            </a:r>
+          </a:p>
+          <a:p>
+            <a:pPr algn="ctr">
+              <a:spcBef>
+                <a:spcPts val="0"/>
+              </a:spcBef>
+              <a:spcAft>
+                <a:spcPts val="0"/>
+              </a:spcAft>
+            </a:pPr>
+            <a:r>
+              <a:rPr sz="1300" b="0" i="0">
+                <a:solidFill>
+                  <a:srgbClr val="5A6472"/>
+                </a:solidFill>
+                <a:latin typeface="Segoe UI"/>
+              </a:rPr>
+              <a:t>parameters</a:t>
+            </a:r>
+          </a:p>
+        </p:txBody>
+      </p:sp>
+      <p:sp>
+        <p:nvSpPr>
+          <p:cNvPr id="11" name="TextBox 10"/>
           <p:cNvSpPr txBox="1"/>
           <p:nvPr/>
         </p:nvSpPr>
@@ -4650,7 +4286,7 @@
                 </a:solidFill>
                 <a:latin typeface="Segoe UI"/>
               </a:rPr>
-              <a:t>THE MODEL</a:t>
+              <a:t>STAGE 1 · SUPERVISED</a:t>
             </a:r>
           </a:p>
           <a:p>
@@ -4665,11 +4301,11 @@
             <a:r>
               <a:rPr sz="3300" b="1" i="0">
                 <a:solidFill>
-                  <a:srgbClr val="1A1D24"/>
-                </a:solidFill>
-                <a:latin typeface="Segoe UI"/>
-              </a:rPr>
-              <a:t>A residual policy–value network</a:t>
+                  <a:srgbClr val="1A7F4B"/>
+                </a:solidFill>
+                <a:latin typeface="Segoe UI"/>
+              </a:rPr>
+              <a:t>Learning from 677k human positions</a:t>
             </a:r>
           </a:p>
         </p:txBody>
@@ -4718,16 +4354,40 @@
           </a:p>
         </p:txBody>
       </p:sp>
-      <p:sp>
-        <p:nvSpPr>
-          <p:cNvPr id="4" name="TextBox 3"/>
+      <p:pic>
+        <p:nvPicPr>
+          <p:cNvPr id="4" name="Picture 3" descr="pretrain_loss.png"/>
+          <p:cNvPicPr>
+            <a:picLocks noChangeAspect="1"/>
+          </p:cNvPicPr>
+          <p:nvPr/>
+        </p:nvPicPr>
+        <p:blipFill>
+          <a:blip r:embed="rId2"/>
+          <a:stretch>
+            <a:fillRect/>
+          </a:stretch>
+        </p:blipFill>
+        <p:spPr>
+          <a:xfrm>
+            <a:off x="685800" y="2011680"/>
+            <a:ext cx="5486400" cy="4291509"/>
+          </a:xfrm>
+          <a:prstGeom prst="rect">
+            <a:avLst/>
+          </a:prstGeom>
+        </p:spPr>
+      </p:pic>
+      <p:sp>
+        <p:nvSpPr>
+          <p:cNvPr id="5" name="TextBox 4"/>
           <p:cNvSpPr txBox="1"/>
           <p:nvPr/>
         </p:nvSpPr>
         <p:spPr>
           <a:xfrm>
-            <a:off x="685800" y="1965960"/>
-            <a:ext cx="6675120" cy="4343400"/>
+            <a:off x="6492240" y="2103120"/>
+            <a:ext cx="5029200" cy="4206240"/>
           </a:xfrm>
           <a:prstGeom prst="rect">
             <a:avLst/>
@@ -4749,13 +4409,13 @@
               </a:spcAft>
             </a:pPr>
             <a:r>
-              <a:rPr sz="1800" b="0" i="0">
+              <a:rPr sz="1600" b="1" i="0">
                 <a:solidFill>
                   <a:srgbClr val="1A1D24"/>
                 </a:solidFill>
                 <a:latin typeface="Segoe UI"/>
               </a:rPr>
-              <a:t>3×3 convolution: 18 planes → 64 channels</a:t>
+              <a:t>Lichess database, both players rated 1750+</a:t>
             </a:r>
           </a:p>
           <a:p>
@@ -4768,13 +4428,13 @@
               </a:spcAft>
             </a:pPr>
             <a:r>
-              <a:rPr sz="1800" b="0" i="0">
+              <a:rPr sz="1600" b="0" i="0">
                 <a:solidFill>
                   <a:srgbClr val="1A1D24"/>
                 </a:solidFill>
                 <a:latin typeface="Segoe UI"/>
               </a:rPr>
-              <a:t>10 residual blocks, 64 filters, batch normalisation</a:t>
+              <a:t>The Elo filter keeps only ~12% of games — imitate competent play, not average play.</a:t>
             </a:r>
           </a:p>
           <a:p>
@@ -4787,13 +4447,13 @@
               </a:spcAft>
             </a:pPr>
             <a:r>
-              <a:rPr sz="1800" b="1" i="0">
-                <a:solidFill>
-                  <a:srgbClr val="1F4E9C"/>
-                </a:solidFill>
-                <a:latin typeface="Segoe UI"/>
-              </a:rPr>
-              <a:t>Policy head → 4,672 logits   ·   Value head → one scalar</a:t>
+              <a:rPr sz="1600" b="1" i="0">
+                <a:solidFill>
+                  <a:srgbClr val="1A7F4B"/>
+                </a:solidFill>
+                <a:latin typeface="Segoe UI"/>
+              </a:rPr>
+              <a:t>Policy cross-entropy 3.90 → 2.06</a:t>
             </a:r>
           </a:p>
           <a:p>
@@ -4806,13 +4466,13 @@
               </a:spcAft>
             </a:pPr>
             <a:r>
-              <a:rPr sz="1800" b="0" i="0">
+              <a:rPr sz="1600" b="0" i="0">
                 <a:solidFill>
                   <a:srgbClr val="1A1D24"/>
                 </a:solidFill>
                 <a:latin typeface="Segoe UI"/>
               </a:rPr>
-              <a:t>Both heads share the trunk — the representation must serve two tasks at once.</a:t>
+              <a:t>≈ 13% probability on the exact move a strong human chose, out of 4,672 options.</a:t>
             </a:r>
           </a:p>
           <a:p>
@@ -4825,265 +4485,13 @@
               </a:spcAft>
             </a:pPr>
             <a:r>
-              <a:rPr sz="1800" b="0" i="0">
-                <a:solidFill>
-                  <a:srgbClr val="1A1D24"/>
-                </a:solidFill>
-                <a:latin typeface="Segoe UI"/>
-              </a:rPr>
-              <a:t>Trained with the AlphaZero loss: cross-entropy on the search distribution, plus MSE on the game result.</a:t>
-            </a:r>
-          </a:p>
-        </p:txBody>
-      </p:sp>
-      <p:sp>
-        <p:nvSpPr>
-          <p:cNvPr id="5" name="Rectangle 4"/>
-          <p:cNvSpPr/>
-          <p:nvPr/>
-        </p:nvSpPr>
-        <p:spPr>
-          <a:xfrm>
-            <a:off x="7955279" y="2194560"/>
-            <a:ext cx="3474720" cy="1508760"/>
-          </a:xfrm>
-          <a:prstGeom prst="rect">
-            <a:avLst/>
-          </a:prstGeom>
-          <a:solidFill>
-            <a:srgbClr val="F2F5F9"/>
-          </a:solidFill>
-          <a:ln>
-            <a:noFill/>
-          </a:ln>
-          <a:effectLst/>
-        </p:spPr>
-        <p:style>
-          <a:lnRef idx="1">
-            <a:schemeClr val="accent1"/>
-          </a:lnRef>
-          <a:fillRef idx="3">
-            <a:schemeClr val="accent1"/>
-          </a:fillRef>
-          <a:effectRef idx="2">
-            <a:schemeClr val="accent1"/>
-          </a:effectRef>
-          <a:fontRef idx="minor">
-            <a:schemeClr val="lt1"/>
-          </a:fontRef>
-        </p:style>
-        <p:txBody>
-          <a:bodyPr rtlCol="0" anchor="ctr"/>
-          <a:lstStyle/>
-          <a:p>
-            <a:pPr algn="ctr"/>
-          </a:p>
-        </p:txBody>
-      </p:sp>
-      <p:sp>
-        <p:nvSpPr>
-          <p:cNvPr id="6" name="TextBox 5"/>
-          <p:cNvSpPr txBox="1"/>
-          <p:nvPr/>
-        </p:nvSpPr>
-        <p:spPr>
-          <a:xfrm>
-            <a:off x="7955279" y="2359152"/>
-            <a:ext cx="3474720" cy="1188720"/>
-          </a:xfrm>
-          <a:prstGeom prst="rect">
-            <a:avLst/>
-          </a:prstGeom>
-          <a:noFill/>
-        </p:spPr>
-        <p:txBody>
-          <a:bodyPr wrap="square">
-            <a:spAutoFit/>
-          </a:bodyPr>
-          <a:lstStyle/>
-          <a:p>
-            <a:pPr algn="ctr">
-              <a:spcBef>
-                <a:spcPts val="0"/>
-              </a:spcBef>
-              <a:spcAft>
-                <a:spcPts val="200"/>
-              </a:spcAft>
-            </a:pPr>
-            <a:r>
-              <a:rPr sz="4400" b="1" i="0">
-                <a:solidFill>
-                  <a:srgbClr val="B87A14"/>
-                </a:solidFill>
-                <a:latin typeface="Segoe UI"/>
-              </a:rPr>
-              <a:t>~1000×</a:t>
-            </a:r>
-          </a:p>
-          <a:p>
-            <a:pPr algn="ctr">
-              <a:spcBef>
-                <a:spcPts val="0"/>
-              </a:spcBef>
-              <a:spcAft>
-                <a:spcPts val="0"/>
-              </a:spcAft>
-            </a:pPr>
-            <a:r>
-              <a:rPr sz="1300" b="0" i="0">
-                <a:solidFill>
-                  <a:srgbClr val="5A6472"/>
-                </a:solidFill>
-                <a:latin typeface="Segoe UI"/>
-              </a:rPr>
-              <a:t>smaller than AlphaZero</a:t>
-            </a:r>
-          </a:p>
-        </p:txBody>
-      </p:sp>
-      <p:sp>
-        <p:nvSpPr>
-          <p:cNvPr id="7" name="Rectangle 6"/>
-          <p:cNvSpPr/>
-          <p:nvPr/>
-        </p:nvSpPr>
-        <p:spPr>
-          <a:xfrm>
-            <a:off x="7955279" y="3886200"/>
-            <a:ext cx="3474720" cy="1508760"/>
-          </a:xfrm>
-          <a:prstGeom prst="rect">
-            <a:avLst/>
-          </a:prstGeom>
-          <a:solidFill>
-            <a:srgbClr val="F2F5F9"/>
-          </a:solidFill>
-          <a:ln>
-            <a:noFill/>
-          </a:ln>
-          <a:effectLst/>
-        </p:spPr>
-        <p:style>
-          <a:lnRef idx="1">
-            <a:schemeClr val="accent1"/>
-          </a:lnRef>
-          <a:fillRef idx="3">
-            <a:schemeClr val="accent1"/>
-          </a:fillRef>
-          <a:effectRef idx="2">
-            <a:schemeClr val="accent1"/>
-          </a:effectRef>
-          <a:fontRef idx="minor">
-            <a:schemeClr val="lt1"/>
-          </a:fontRef>
-        </p:style>
-        <p:txBody>
-          <a:bodyPr rtlCol="0" anchor="ctr"/>
-          <a:lstStyle/>
-          <a:p>
-            <a:pPr algn="ctr"/>
-          </a:p>
-        </p:txBody>
-      </p:sp>
-      <p:sp>
-        <p:nvSpPr>
-          <p:cNvPr id="8" name="TextBox 7"/>
-          <p:cNvSpPr txBox="1"/>
-          <p:nvPr/>
-        </p:nvSpPr>
-        <p:spPr>
-          <a:xfrm>
-            <a:off x="7955279" y="4050792"/>
-            <a:ext cx="3474720" cy="1188720"/>
-          </a:xfrm>
-          <a:prstGeom prst="rect">
-            <a:avLst/>
-          </a:prstGeom>
-          <a:noFill/>
-        </p:spPr>
-        <p:txBody>
-          <a:bodyPr wrap="square">
-            <a:spAutoFit/>
-          </a:bodyPr>
-          <a:lstStyle/>
-          <a:p>
-            <a:pPr algn="ctr">
-              <a:spcBef>
-                <a:spcPts val="0"/>
-              </a:spcBef>
-              <a:spcAft>
-                <a:spcPts val="200"/>
-              </a:spcAft>
-            </a:pPr>
-            <a:r>
-              <a:rPr sz="2600" b="1" i="0">
-                <a:solidFill>
-                  <a:srgbClr val="5A6472"/>
-                </a:solidFill>
-                <a:latin typeface="Segoe UI"/>
-              </a:rPr>
-              <a:t>6 CPU + 1 GPU</a:t>
-            </a:r>
-          </a:p>
-          <a:p>
-            <a:pPr algn="ctr">
-              <a:spcBef>
-                <a:spcPts val="0"/>
-              </a:spcBef>
-              <a:spcAft>
-                <a:spcPts val="0"/>
-              </a:spcAft>
-            </a:pPr>
-            <a:r>
-              <a:rPr sz="1300" b="0" i="0">
-                <a:solidFill>
-                  <a:srgbClr val="5A6472"/>
-                </a:solidFill>
-                <a:latin typeface="Segoe UI"/>
-              </a:rPr>
-              <a:t>self-play on cores, training on GPU</a:t>
-            </a:r>
-          </a:p>
-        </p:txBody>
-      </p:sp>
-      <p:sp>
-        <p:nvSpPr>
-          <p:cNvPr id="9" name="TextBox 8"/>
-          <p:cNvSpPr txBox="1"/>
-          <p:nvPr/>
-        </p:nvSpPr>
-        <p:spPr>
-          <a:xfrm>
-            <a:off x="685800" y="5943600"/>
-            <a:ext cx="10820095" cy="502920"/>
-          </a:xfrm>
-          <a:prstGeom prst="rect">
-            <a:avLst/>
-          </a:prstGeom>
-          <a:noFill/>
-        </p:spPr>
-        <p:txBody>
-          <a:bodyPr wrap="square">
-            <a:spAutoFit/>
-          </a:bodyPr>
-          <a:lstStyle/>
-          <a:p>
-            <a:pPr algn="l">
-              <a:spcBef>
-                <a:spcPts val="0"/>
-              </a:spcBef>
-              <a:spcAft>
-                <a:spcPts val="600"/>
-              </a:spcAft>
-            </a:pPr>
-            <a:r>
-              <a:rPr sz="1500" b="0" i="1">
-                <a:solidFill>
-                  <a:srgbClr val="5A6472"/>
-                </a:solidFill>
-                <a:latin typeface="Segoe UI"/>
-              </a:rPr>
-              <a:t>Self-play is CPU-bound; the GPU only does batched gradient steps.</a:t>
+              <a:rPr sz="1600" b="1" i="0">
+                <a:solidFill>
+                  <a:srgbClr val="1A7F4B"/>
+                </a:solidFill>
+                <a:latin typeface="Segoe UI"/>
+              </a:rPr>
+              <a:t>It plays real chess: e4/d4 openings, wins a hanging queen, finds mate in one. 85% vs random.</a:t>
             </a:r>
           </a:p>
         </p:txBody>
@@ -5151,7 +4559,7 @@
                 </a:solidFill>
                 <a:latin typeface="Segoe UI"/>
               </a:rPr>
-              <a:t>STAGE 1 · SUPERVISED</a:t>
+              <a:t>STAGE 2 · SELF-PLAY</a:t>
             </a:r>
           </a:p>
           <a:p>
@@ -5166,11 +4574,11 @@
             <a:r>
               <a:rPr sz="3300" b="1" i="0">
                 <a:solidFill>
-                  <a:srgbClr val="1A7F4B"/>
-                </a:solidFill>
-                <a:latin typeface="Segoe UI"/>
-              </a:rPr>
-              <a:t>Learning from 677k human positions</a:t>
+                  <a:srgbClr val="1A1D24"/>
+                </a:solidFill>
+                <a:latin typeface="Segoe UI"/>
+              </a:rPr>
+              <a:t>300 iterations. The loss fell the whole way.</a:t>
             </a:r>
           </a:p>
         </p:txBody>
@@ -5221,7 +4629,7 @@
       </p:sp>
       <p:pic>
         <p:nvPicPr>
-          <p:cNvPr id="4" name="Picture 3" descr="pretrain_loss.png"/>
+          <p:cNvPr id="4" name="Picture 3" descr="v5_regression.png"/>
           <p:cNvPicPr>
             <a:picLocks noChangeAspect="1"/>
           </p:cNvPicPr>
@@ -5236,7 +4644,7 @@
         <p:spPr>
           <a:xfrm>
             <a:off x="685800" y="2011680"/>
-            <a:ext cx="5486400" cy="4291509"/>
+            <a:ext cx="5486400" cy="3652825"/>
           </a:xfrm>
           <a:prstGeom prst="rect">
             <a:avLst/>
@@ -5274,13 +4682,13 @@
               </a:spcAft>
             </a:pPr>
             <a:r>
-              <a:rPr sz="1600" b="1" i="0">
+              <a:rPr sz="1700" b="1" i="0">
                 <a:solidFill>
                   <a:srgbClr val="1A1D24"/>
                 </a:solidFill>
                 <a:latin typeface="Segoe UI"/>
               </a:rPr>
-              <a:t>Lichess database, both players rated 1750+</a:t>
+              <a:t>Training loss: 2.36 → 1.85</a:t>
             </a:r>
           </a:p>
           <a:p>
@@ -5293,13 +4701,13 @@
               </a:spcAft>
             </a:pPr>
             <a:r>
-              <a:rPr sz="1600" b="0" i="0">
+              <a:rPr sz="1700" b="0" i="0">
                 <a:solidFill>
                   <a:srgbClr val="1A1D24"/>
                 </a:solidFill>
                 <a:latin typeface="Segoe UI"/>
               </a:rPr>
-              <a:t>The Elo filter keeps only ~12% of games — imitate competent play, not average play.</a:t>
+              <a:t>Monotonic. Textbook. Exactly what you hope to see.</a:t>
             </a:r>
           </a:p>
           <a:p>
@@ -5312,13 +4720,13 @@
               </a:spcAft>
             </a:pPr>
             <a:r>
-              <a:rPr sz="1600" b="1" i="0">
-                <a:solidFill>
-                  <a:srgbClr val="1A7F4B"/>
-                </a:solidFill>
-                <a:latin typeface="Segoe UI"/>
-              </a:rPr>
-              <a:t>Policy cross-entropy 3.90 → 2.06</a:t>
+              <a:rPr sz="1700" b="1" i="0">
+                <a:solidFill>
+                  <a:srgbClr val="5A6472"/>
+                </a:solidFill>
+                <a:latin typeface="Segoe UI"/>
+              </a:rPr>
+              <a:t>Reported evaluation score: 50%</a:t>
             </a:r>
           </a:p>
           <a:p>
@@ -5331,13 +4739,13 @@
               </a:spcAft>
             </a:pPr>
             <a:r>
-              <a:rPr sz="1600" b="0" i="0">
+              <a:rPr sz="1700" b="0" i="0">
                 <a:solidFill>
                   <a:srgbClr val="1A1D24"/>
                 </a:solidFill>
                 <a:latin typeface="Segoe UI"/>
               </a:rPr>
-              <a:t>≈ 13% probability on the exact move a strong human chose, out of 4,672 options.</a:t>
+              <a:t>For 159 consecutive measurements across two multi-hour runs.</a:t>
             </a:r>
           </a:p>
           <a:p>
@@ -5350,13 +4758,32 @@
               </a:spcAft>
             </a:pPr>
             <a:r>
-              <a:rPr sz="1600" b="1" i="0">
-                <a:solidFill>
-                  <a:srgbClr val="1A7F4B"/>
-                </a:solidFill>
-                <a:latin typeface="Segoe UI"/>
-              </a:rPr>
-              <a:t>It plays real chess: e4/d4 openings, wins a hanging queen, finds mate in one. 85% vs random.</a:t>
+              <a:rPr sz="1700" b="1" i="0">
+                <a:solidFill>
+                  <a:srgbClr val="B3352C"/>
+                </a:solidFill>
+                <a:latin typeface="Segoe UI"/>
+              </a:rPr>
+              <a:t>I read that as “evenly matched.”</a:t>
+            </a:r>
+          </a:p>
+          <a:p>
+            <a:pPr algn="l">
+              <a:spcBef>
+                <a:spcPts val="0"/>
+              </a:spcBef>
+              <a:spcAft>
+                <a:spcPts val="1300"/>
+              </a:spcAft>
+            </a:pPr>
+            <a:r>
+              <a:rPr sz="1700" b="0" i="0">
+                <a:solidFill>
+                  <a:srgbClr val="1A1D24"/>
+                </a:solidFill>
+                <a:latin typeface="Segoe UI"/>
+              </a:rPr>
+              <a:t>It was not. It was a metric that could not return anything else.</a:t>
             </a:r>
           </a:p>
         </p:txBody>
@@ -5424,7 +4851,7 @@
                 </a:solidFill>
                 <a:latin typeface="Segoe UI"/>
               </a:rPr>
-              <a:t>STAGE 2 · SELF-PLAY</a:t>
+              <a:t>THE BUG</a:t>
             </a:r>
           </a:p>
           <a:p>
@@ -5439,11 +4866,11 @@
             <a:r>
               <a:rPr sz="3300" b="1" i="0">
                 <a:solidFill>
-                  <a:srgbClr val="1A1D24"/>
-                </a:solidFill>
-                <a:latin typeface="Segoe UI"/>
-              </a:rPr>
-              <a:t>300 iterations. The loss fell the whole way.</a:t>
+                  <a:srgbClr val="B3352C"/>
+                </a:solidFill>
+                <a:latin typeface="Segoe UI"/>
+              </a:rPr>
+              <a:t>The evaluation was measuring nothing</a:t>
             </a:r>
           </a:p>
         </p:txBody>
@@ -5492,40 +4919,16 @@
           </a:p>
         </p:txBody>
       </p:sp>
-      <p:pic>
-        <p:nvPicPr>
-          <p:cNvPr id="4" name="Picture 3" descr="v5_regression.png"/>
-          <p:cNvPicPr>
-            <a:picLocks noChangeAspect="1"/>
-          </p:cNvPicPr>
-          <p:nvPr/>
-        </p:nvPicPr>
-        <p:blipFill>
-          <a:blip r:embed="rId2"/>
-          <a:stretch>
-            <a:fillRect/>
-          </a:stretch>
-        </p:blipFill>
-        <p:spPr>
-          <a:xfrm>
-            <a:off x="685800" y="2011680"/>
-            <a:ext cx="5486400" cy="3652825"/>
-          </a:xfrm>
-          <a:prstGeom prst="rect">
-            <a:avLst/>
-          </a:prstGeom>
-        </p:spPr>
-      </p:pic>
-      <p:sp>
-        <p:nvSpPr>
-          <p:cNvPr id="5" name="TextBox 4"/>
+      <p:sp>
+        <p:nvSpPr>
+          <p:cNvPr id="4" name="TextBox 3"/>
           <p:cNvSpPr txBox="1"/>
           <p:nvPr/>
         </p:nvSpPr>
         <p:spPr>
           <a:xfrm>
-            <a:off x="6492240" y="2103120"/>
-            <a:ext cx="5029200" cy="4206240"/>
+            <a:off x="685800" y="1920240"/>
+            <a:ext cx="5989320" cy="4389120"/>
           </a:xfrm>
           <a:prstGeom prst="rect">
             <a:avLst/>
@@ -5547,13 +4950,13 @@
               </a:spcAft>
             </a:pPr>
             <a:r>
-              <a:rPr sz="1700" b="1" i="0">
+              <a:rPr sz="1800" b="0" i="0">
                 <a:solidFill>
                   <a:srgbClr val="1A1D24"/>
                 </a:solidFill>
                 <a:latin typeface="Segoe UI"/>
               </a:rPr>
-              <a:t>Training loss: 2.36 → 1.85</a:t>
+              <a:t>The network alternated colours — half its games as white, half as black.</a:t>
             </a:r>
           </a:p>
           <a:p>
@@ -5566,13 +4969,32 @@
               </a:spcAft>
             </a:pPr>
             <a:r>
-              <a:rPr sz="1700" b="0" i="0">
+              <a:rPr sz="1800" b="1" i="0">
+                <a:solidFill>
+                  <a:srgbClr val="B3352C"/>
+                </a:solidFill>
+                <a:latin typeface="Segoe UI"/>
+              </a:rPr>
+              <a:t>The score counted white’s wins.</a:t>
+            </a:r>
+          </a:p>
+          <a:p>
+            <a:pPr algn="l">
+              <a:spcBef>
+                <a:spcPts val="0"/>
+              </a:spcBef>
+              <a:spcAft>
+                <a:spcPts val="1300"/>
+              </a:spcAft>
+            </a:pPr>
+            <a:r>
+              <a:rPr sz="1800" b="0" i="0">
                 <a:solidFill>
                   <a:srgbClr val="1A1D24"/>
                 </a:solidFill>
                 <a:latin typeface="Segoe UI"/>
               </a:rPr>
-              <a:t>Monotonic. Textbook. Exactly what you hope to see.</a:t>
+              <a:t>So every game the network won as black was recorded as a loss.</a:t>
             </a:r>
           </a:p>
           <a:p>
@@ -5585,70 +5007,364 @@
               </a:spcAft>
             </a:pPr>
             <a:r>
-              <a:rPr sz="1700" b="1" i="0">
+              <a:rPr sz="1800" b="0" i="0">
+                <a:solidFill>
+                  <a:srgbClr val="1A1D24"/>
+                </a:solidFill>
+                <a:latin typeface="Segoe UI"/>
+              </a:rPr>
+              <a:t>With two deterministic players and no opening randomisation, all five games per colour are identical — the tally can only be symmetric.</a:t>
+            </a:r>
+          </a:p>
+        </p:txBody>
+      </p:sp>
+      <p:sp>
+        <p:nvSpPr>
+          <p:cNvPr id="5" name="Rectangle 4"/>
+          <p:cNvSpPr/>
+          <p:nvPr/>
+        </p:nvSpPr>
+        <p:spPr>
+          <a:xfrm>
+            <a:off x="6949440" y="2194560"/>
+            <a:ext cx="4572000" cy="1097280"/>
+          </a:xfrm>
+          <a:prstGeom prst="rect">
+            <a:avLst/>
+          </a:prstGeom>
+          <a:solidFill>
+            <a:srgbClr val="F7F7F4"/>
+          </a:solidFill>
+          <a:ln>
+            <a:noFill/>
+          </a:ln>
+          <a:effectLst/>
+        </p:spPr>
+        <p:style>
+          <a:lnRef idx="1">
+            <a:schemeClr val="accent1"/>
+          </a:lnRef>
+          <a:fillRef idx="3">
+            <a:schemeClr val="accent1"/>
+          </a:fillRef>
+          <a:effectRef idx="2">
+            <a:schemeClr val="accent1"/>
+          </a:effectRef>
+          <a:fontRef idx="minor">
+            <a:schemeClr val="lt1"/>
+          </a:fontRef>
+        </p:style>
+        <p:txBody>
+          <a:bodyPr rtlCol="0" anchor="ctr"/>
+          <a:lstStyle/>
+          <a:p>
+            <a:pPr algn="ctr"/>
+          </a:p>
+        </p:txBody>
+      </p:sp>
+      <p:sp>
+        <p:nvSpPr>
+          <p:cNvPr id="6" name="TextBox 5"/>
+          <p:cNvSpPr txBox="1"/>
+          <p:nvPr/>
+        </p:nvSpPr>
+        <p:spPr>
+          <a:xfrm>
+            <a:off x="7150608" y="2340864"/>
+            <a:ext cx="4206240" cy="1097280"/>
+          </a:xfrm>
+          <a:prstGeom prst="rect">
+            <a:avLst/>
+          </a:prstGeom>
+          <a:noFill/>
+        </p:spPr>
+        <p:txBody>
+          <a:bodyPr wrap="square">
+            <a:spAutoFit/>
+          </a:bodyPr>
+          <a:lstStyle/>
+          <a:p>
+            <a:pPr>
+              <a:spcAft>
+                <a:spcPts val="500"/>
+              </a:spcAft>
+            </a:pPr>
+            <a:r>
+              <a:rPr sz="1300">
                 <a:solidFill>
                   <a:srgbClr val="5A6472"/>
                 </a:solidFill>
-                <a:latin typeface="Segoe UI"/>
-              </a:rPr>
-              <a:t>Reported evaluation score: 50%</a:t>
-            </a:r>
-          </a:p>
-          <a:p>
-            <a:pPr algn="l">
-              <a:spcBef>
-                <a:spcPts val="0"/>
-              </a:spcBef>
-              <a:spcAft>
-                <a:spcPts val="1300"/>
-              </a:spcAft>
-            </a:pPr>
-            <a:r>
-              <a:rPr sz="1700" b="0" i="0">
-                <a:solidFill>
-                  <a:srgbClr val="1A1D24"/>
-                </a:solidFill>
-                <a:latin typeface="Segoe UI"/>
-              </a:rPr>
-              <a:t>For 159 consecutive measurements across two multi-hour runs.</a:t>
-            </a:r>
-          </a:p>
-          <a:p>
-            <a:pPr algn="l">
-              <a:spcBef>
-                <a:spcPts val="0"/>
-              </a:spcBef>
-              <a:spcAft>
-                <a:spcPts val="1300"/>
-              </a:spcAft>
-            </a:pPr>
-            <a:r>
-              <a:rPr sz="1700" b="1" i="0">
+                <a:latin typeface="Consolas"/>
+              </a:rPr>
+              <a:t>[iter 454] eval: {'1-0': 0, '0-1': 0, '1/2-1/2': 10}  50%</a:t>
+            </a:r>
+          </a:p>
+          <a:p>
+            <a:pPr>
+              <a:spcAft>
+                <a:spcPts val="500"/>
+              </a:spcAft>
+            </a:pPr>
+            <a:r>
+              <a:rPr sz="1300">
+                <a:solidFill>
+                  <a:srgbClr val="5A6472"/>
+                </a:solidFill>
+                <a:latin typeface="Consolas"/>
+              </a:rPr>
+              <a:t>[iter 499] eval: {'1-0': 0, '0-1': 0, '1/2-1/2': 10}  50%</a:t>
+            </a:r>
+          </a:p>
+        </p:txBody>
+      </p:sp>
+      <p:sp>
+        <p:nvSpPr>
+          <p:cNvPr id="7" name="Rectangle 6"/>
+          <p:cNvSpPr/>
+          <p:nvPr/>
+        </p:nvSpPr>
+        <p:spPr>
+          <a:xfrm>
+            <a:off x="6949440" y="3657600"/>
+            <a:ext cx="2148840" cy="1508760"/>
+          </a:xfrm>
+          <a:prstGeom prst="rect">
+            <a:avLst/>
+          </a:prstGeom>
+          <a:solidFill>
+            <a:srgbClr val="F2F5F9"/>
+          </a:solidFill>
+          <a:ln>
+            <a:noFill/>
+          </a:ln>
+          <a:effectLst/>
+        </p:spPr>
+        <p:style>
+          <a:lnRef idx="1">
+            <a:schemeClr val="accent1"/>
+          </a:lnRef>
+          <a:fillRef idx="3">
+            <a:schemeClr val="accent1"/>
+          </a:fillRef>
+          <a:effectRef idx="2">
+            <a:schemeClr val="accent1"/>
+          </a:effectRef>
+          <a:fontRef idx="minor">
+            <a:schemeClr val="lt1"/>
+          </a:fontRef>
+        </p:style>
+        <p:txBody>
+          <a:bodyPr rtlCol="0" anchor="ctr"/>
+          <a:lstStyle/>
+          <a:p>
+            <a:pPr algn="ctr"/>
+          </a:p>
+        </p:txBody>
+      </p:sp>
+      <p:sp>
+        <p:nvSpPr>
+          <p:cNvPr id="8" name="TextBox 7"/>
+          <p:cNvSpPr txBox="1"/>
+          <p:nvPr/>
+        </p:nvSpPr>
+        <p:spPr>
+          <a:xfrm>
+            <a:off x="6949440" y="3822192"/>
+            <a:ext cx="2148840" cy="1188720"/>
+          </a:xfrm>
+          <a:prstGeom prst="rect">
+            <a:avLst/>
+          </a:prstGeom>
+          <a:noFill/>
+        </p:spPr>
+        <p:txBody>
+          <a:bodyPr wrap="square">
+            <a:spAutoFit/>
+          </a:bodyPr>
+          <a:lstStyle/>
+          <a:p>
+            <a:pPr algn="ctr">
+              <a:spcBef>
+                <a:spcPts val="0"/>
+              </a:spcBef>
+              <a:spcAft>
+                <a:spcPts val="200"/>
+              </a:spcAft>
+            </a:pPr>
+            <a:r>
+              <a:rPr sz="4000" b="1" i="0">
                 <a:solidFill>
                   <a:srgbClr val="B3352C"/>
                 </a:solidFill>
                 <a:latin typeface="Segoe UI"/>
               </a:rPr>
-              <a:t>I read that as “evenly matched.”</a:t>
-            </a:r>
-          </a:p>
-          <a:p>
-            <a:pPr algn="l">
-              <a:spcBef>
-                <a:spcPts val="0"/>
-              </a:spcBef>
-              <a:spcAft>
-                <a:spcPts val="1300"/>
-              </a:spcAft>
-            </a:pPr>
-            <a:r>
-              <a:rPr sz="1700" b="0" i="0">
-                <a:solidFill>
-                  <a:srgbClr val="1A1D24"/>
-                </a:solidFill>
-                <a:latin typeface="Segoe UI"/>
-              </a:rPr>
-              <a:t>It was not. It was a metric that could not return anything else.</a:t>
+              <a:t>159</a:t>
+            </a:r>
+          </a:p>
+          <a:p>
+            <a:pPr algn="ctr">
+              <a:spcBef>
+                <a:spcPts val="0"/>
+              </a:spcBef>
+              <a:spcAft>
+                <a:spcPts val="0"/>
+              </a:spcAft>
+            </a:pPr>
+            <a:r>
+              <a:rPr sz="1300" b="0" i="0">
+                <a:solidFill>
+                  <a:srgbClr val="5A6472"/>
+                </a:solidFill>
+                <a:latin typeface="Segoe UI"/>
+              </a:rPr>
+              <a:t>useless data points</a:t>
+            </a:r>
+          </a:p>
+        </p:txBody>
+      </p:sp>
+      <p:sp>
+        <p:nvSpPr>
+          <p:cNvPr id="9" name="Rectangle 8"/>
+          <p:cNvSpPr/>
+          <p:nvPr/>
+        </p:nvSpPr>
+        <p:spPr>
+          <a:xfrm>
+            <a:off x="9372600" y="3657600"/>
+            <a:ext cx="2148840" cy="1508760"/>
+          </a:xfrm>
+          <a:prstGeom prst="rect">
+            <a:avLst/>
+          </a:prstGeom>
+          <a:solidFill>
+            <a:srgbClr val="F2F5F9"/>
+          </a:solidFill>
+          <a:ln>
+            <a:noFill/>
+          </a:ln>
+          <a:effectLst/>
+        </p:spPr>
+        <p:style>
+          <a:lnRef idx="1">
+            <a:schemeClr val="accent1"/>
+          </a:lnRef>
+          <a:fillRef idx="3">
+            <a:schemeClr val="accent1"/>
+          </a:fillRef>
+          <a:effectRef idx="2">
+            <a:schemeClr val="accent1"/>
+          </a:effectRef>
+          <a:fontRef idx="minor">
+            <a:schemeClr val="lt1"/>
+          </a:fontRef>
+        </p:style>
+        <p:txBody>
+          <a:bodyPr rtlCol="0" anchor="ctr"/>
+          <a:lstStyle/>
+          <a:p>
+            <a:pPr algn="ctr"/>
+          </a:p>
+        </p:txBody>
+      </p:sp>
+      <p:sp>
+        <p:nvSpPr>
+          <p:cNvPr id="10" name="TextBox 9"/>
+          <p:cNvSpPr txBox="1"/>
+          <p:nvPr/>
+        </p:nvSpPr>
+        <p:spPr>
+          <a:xfrm>
+            <a:off x="9372600" y="3822192"/>
+            <a:ext cx="2148840" cy="1188720"/>
+          </a:xfrm>
+          <a:prstGeom prst="rect">
+            <a:avLst/>
+          </a:prstGeom>
+          <a:noFill/>
+        </p:spPr>
+        <p:txBody>
+          <a:bodyPr wrap="square">
+            <a:spAutoFit/>
+          </a:bodyPr>
+          <a:lstStyle/>
+          <a:p>
+            <a:pPr algn="ctr">
+              <a:spcBef>
+                <a:spcPts val="0"/>
+              </a:spcBef>
+              <a:spcAft>
+                <a:spcPts val="200"/>
+              </a:spcAft>
+            </a:pPr>
+            <a:r>
+              <a:rPr sz="2600" b="1" i="0">
+                <a:solidFill>
+                  <a:srgbClr val="1A7F4B"/>
+                </a:solidFill>
+                <a:latin typeface="Segoe UI"/>
+              </a:rPr>
+              <a:t>44% → 85%</a:t>
+            </a:r>
+          </a:p>
+          <a:p>
+            <a:pPr algn="ctr">
+              <a:spcBef>
+                <a:spcPts val="0"/>
+              </a:spcBef>
+              <a:spcAft>
+                <a:spcPts val="0"/>
+              </a:spcAft>
+            </a:pPr>
+            <a:r>
+              <a:rPr sz="1300" b="0" i="0">
+                <a:solidFill>
+                  <a:srgbClr val="5A6472"/>
+                </a:solidFill>
+                <a:latin typeface="Segoe UI"/>
+              </a:rPr>
+              <a:t>true score, once fixed</a:t>
+            </a:r>
+          </a:p>
+        </p:txBody>
+      </p:sp>
+      <p:sp>
+        <p:nvSpPr>
+          <p:cNvPr id="11" name="TextBox 10"/>
+          <p:cNvSpPr txBox="1"/>
+          <p:nvPr/>
+        </p:nvSpPr>
+        <p:spPr>
+          <a:xfrm>
+            <a:off x="685800" y="5943600"/>
+            <a:ext cx="10820095" cy="502920"/>
+          </a:xfrm>
+          <a:prstGeom prst="rect">
+            <a:avLst/>
+          </a:prstGeom>
+          <a:noFill/>
+        </p:spPr>
+        <p:txBody>
+          <a:bodyPr wrap="square">
+            <a:spAutoFit/>
+          </a:bodyPr>
+          <a:lstStyle/>
+          <a:p>
+            <a:pPr algn="l">
+              <a:spcBef>
+                <a:spcPts val="0"/>
+              </a:spcBef>
+              <a:spcAft>
+                <a:spcPts val="600"/>
+              </a:spcAft>
+            </a:pPr>
+            <a:r>
+              <a:rPr sz="1500" b="0" i="1">
+                <a:solidFill>
+                  <a:srgbClr val="5A6472"/>
+                </a:solidFill>
+                <a:latin typeface="Segoe UI"/>
+              </a:rPr>
+              <a:t>A metric returning a plausible constant is more dangerous than one that crashes.</a:t>
             </a:r>
           </a:p>
         </p:txBody>
@@ -5716,7 +5432,7 @@
                 </a:solidFill>
                 <a:latin typeface="Segoe UI"/>
               </a:rPr>
-              <a:t>THE BUG</a:t>
+              <a:t>THE REAL RESULT</a:t>
             </a:r>
           </a:p>
           <a:p>
@@ -5735,7 +5451,7 @@
                 </a:solidFill>
                 <a:latin typeface="Segoe UI"/>
               </a:rPr>
-              <a:t>The evaluation was measuring nothing</a:t>
+              <a:t>Self-play made the model worse</a:t>
             </a:r>
           </a:p>
         </p:txBody>
@@ -5786,119 +5502,20 @@
       </p:sp>
       <p:sp>
         <p:nvSpPr>
-          <p:cNvPr id="4" name="TextBox 3"/>
-          <p:cNvSpPr txBox="1"/>
-          <p:nvPr/>
-        </p:nvSpPr>
-        <p:spPr>
-          <a:xfrm>
-            <a:off x="685800" y="1920240"/>
-            <a:ext cx="5989320" cy="4389120"/>
-          </a:xfrm>
-          <a:prstGeom prst="rect">
-            <a:avLst/>
-          </a:prstGeom>
-          <a:noFill/>
-        </p:spPr>
-        <p:txBody>
-          <a:bodyPr wrap="square">
-            <a:spAutoFit/>
-          </a:bodyPr>
-          <a:lstStyle/>
-          <a:p>
-            <a:pPr algn="l">
-              <a:spcBef>
-                <a:spcPts val="0"/>
-              </a:spcBef>
-              <a:spcAft>
-                <a:spcPts val="1300"/>
-              </a:spcAft>
-            </a:pPr>
-            <a:r>
-              <a:rPr sz="1800" b="0" i="0">
-                <a:solidFill>
-                  <a:srgbClr val="1A1D24"/>
-                </a:solidFill>
-                <a:latin typeface="Segoe UI"/>
-              </a:rPr>
-              <a:t>The network alternated colours — half its games as white, half as black.</a:t>
-            </a:r>
-          </a:p>
-          <a:p>
-            <a:pPr algn="l">
-              <a:spcBef>
-                <a:spcPts val="0"/>
-              </a:spcBef>
-              <a:spcAft>
-                <a:spcPts val="1300"/>
-              </a:spcAft>
-            </a:pPr>
-            <a:r>
-              <a:rPr sz="1800" b="1" i="0">
-                <a:solidFill>
-                  <a:srgbClr val="B3352C"/>
-                </a:solidFill>
-                <a:latin typeface="Segoe UI"/>
-              </a:rPr>
-              <a:t>The score counted white’s wins.</a:t>
-            </a:r>
-          </a:p>
-          <a:p>
-            <a:pPr algn="l">
-              <a:spcBef>
-                <a:spcPts val="0"/>
-              </a:spcBef>
-              <a:spcAft>
-                <a:spcPts val="1300"/>
-              </a:spcAft>
-            </a:pPr>
-            <a:r>
-              <a:rPr sz="1800" b="0" i="0">
-                <a:solidFill>
-                  <a:srgbClr val="1A1D24"/>
-                </a:solidFill>
-                <a:latin typeface="Segoe UI"/>
-              </a:rPr>
-              <a:t>So every game the network won as black was recorded as a loss.</a:t>
-            </a:r>
-          </a:p>
-          <a:p>
-            <a:pPr algn="l">
-              <a:spcBef>
-                <a:spcPts val="0"/>
-              </a:spcBef>
-              <a:spcAft>
-                <a:spcPts val="1300"/>
-              </a:spcAft>
-            </a:pPr>
-            <a:r>
-              <a:rPr sz="1800" b="0" i="0">
-                <a:solidFill>
-                  <a:srgbClr val="1A1D24"/>
-                </a:solidFill>
-                <a:latin typeface="Segoe UI"/>
-              </a:rPr>
-              <a:t>With two deterministic players and no opening randomisation, all five games per colour are identical — the tally can only be symmetric.</a:t>
-            </a:r>
-          </a:p>
-        </p:txBody>
-      </p:sp>
-      <p:sp>
-        <p:nvSpPr>
-          <p:cNvPr id="5" name="Rectangle 4"/>
+          <p:cNvPr id="4" name="Rectangle 3"/>
           <p:cNvSpPr/>
           <p:nvPr/>
         </p:nvSpPr>
         <p:spPr>
           <a:xfrm>
-            <a:off x="6949440" y="2194560"/>
-            <a:ext cx="4572000" cy="1097280"/>
+            <a:off x="685800" y="2103120"/>
+            <a:ext cx="10820095" cy="1737360"/>
           </a:xfrm>
           <a:prstGeom prst="rect">
             <a:avLst/>
           </a:prstGeom>
           <a:solidFill>
-            <a:srgbClr val="F7F7F4"/>
+            <a:srgbClr val="FBF0EF"/>
           </a:solidFill>
           <a:ln>
             <a:noFill/>
@@ -5929,14 +5546,14 @@
       </p:sp>
       <p:sp>
         <p:nvSpPr>
-          <p:cNvPr id="6" name="TextBox 5"/>
+          <p:cNvPr id="5" name="TextBox 4"/>
           <p:cNvSpPr txBox="1"/>
           <p:nvPr/>
         </p:nvSpPr>
         <p:spPr>
           <a:xfrm>
-            <a:off x="7150608" y="2340864"/>
-            <a:ext cx="4206240" cy="1097280"/>
+            <a:off x="685800" y="2331720"/>
+            <a:ext cx="10820095" cy="1371600"/>
           </a:xfrm>
           <a:prstGeom prst="rect">
             <a:avLst/>
@@ -5949,93 +5566,55 @@
           </a:bodyPr>
           <a:lstStyle/>
           <a:p>
-            <a:pPr>
-              <a:spcAft>
-                <a:spcPts val="500"/>
-              </a:spcAft>
-            </a:pPr>
-            <a:r>
-              <a:rPr sz="1300">
+            <a:pPr algn="ctr">
+              <a:spcBef>
+                <a:spcPts val="0"/>
+              </a:spcBef>
+              <a:spcAft>
+                <a:spcPts val="600"/>
+              </a:spcAft>
+            </a:pPr>
+            <a:r>
+              <a:rPr sz="4000" b="1" i="0">
+                <a:solidFill>
+                  <a:srgbClr val="B3352C"/>
+                </a:solidFill>
+                <a:latin typeface="Segoe UI"/>
+              </a:rPr>
+              <a:t>v5 final   2.5  —  5.5   its own starting point</a:t>
+            </a:r>
+          </a:p>
+          <a:p>
+            <a:pPr algn="ctr">
+              <a:spcBef>
+                <a:spcPts val="0"/>
+              </a:spcBef>
+              <a:spcAft>
+                <a:spcPts val="0"/>
+              </a:spcAft>
+            </a:pPr>
+            <a:r>
+              <a:rPr sz="1500" b="0" i="0">
                 <a:solidFill>
                   <a:srgbClr val="5A6472"/>
                 </a:solidFill>
-                <a:latin typeface="Consolas"/>
-              </a:rPr>
-              <a:t>[iter 454] eval: {'1-0': 0, '0-1': 0, '1/2-1/2': 10}  50%</a:t>
-            </a:r>
-          </a:p>
-          <a:p>
-            <a:pPr>
-              <a:spcAft>
-                <a:spcPts val="500"/>
-              </a:spcAft>
-            </a:pPr>
-            <a:r>
-              <a:rPr sz="1300">
-                <a:solidFill>
-                  <a:srgbClr val="5A6472"/>
-                </a:solidFill>
-                <a:latin typeface="Consolas"/>
-              </a:rPr>
-              <a:t>[iter 499] eval: {'1-0': 0, '0-1': 0, '1/2-1/2': 10}  50%</a:t>
-            </a:r>
-          </a:p>
-        </p:txBody>
-      </p:sp>
-      <p:sp>
-        <p:nvSpPr>
-          <p:cNvPr id="7" name="Rectangle 6"/>
-          <p:cNvSpPr/>
-          <p:nvPr/>
-        </p:nvSpPr>
-        <p:spPr>
-          <a:xfrm>
-            <a:off x="6949440" y="3657600"/>
-            <a:ext cx="2148840" cy="1508760"/>
-          </a:xfrm>
-          <a:prstGeom prst="rect">
-            <a:avLst/>
-          </a:prstGeom>
-          <a:solidFill>
-            <a:srgbClr val="F2F5F9"/>
-          </a:solidFill>
-          <a:ln>
-            <a:noFill/>
-          </a:ln>
-          <a:effectLst/>
-        </p:spPr>
-        <p:style>
-          <a:lnRef idx="1">
-            <a:schemeClr val="accent1"/>
-          </a:lnRef>
-          <a:fillRef idx="3">
-            <a:schemeClr val="accent1"/>
-          </a:fillRef>
-          <a:effectRef idx="2">
-            <a:schemeClr val="accent1"/>
-          </a:effectRef>
-          <a:fontRef idx="minor">
-            <a:schemeClr val="lt1"/>
-          </a:fontRef>
-        </p:style>
-        <p:txBody>
-          <a:bodyPr rtlCol="0" anchor="ctr"/>
-          <a:lstStyle/>
-          <a:p>
-            <a:pPr algn="ctr"/>
-          </a:p>
-        </p:txBody>
-      </p:sp>
-      <p:sp>
-        <p:nvSpPr>
-          <p:cNvPr id="8" name="TextBox 7"/>
+                <a:latin typeface="Segoe UI"/>
+              </a:rPr>
+              <a:t>8 games, alternating colours, randomised openings</a:t>
+            </a:r>
+          </a:p>
+        </p:txBody>
+      </p:sp>
+      <p:sp>
+        <p:nvSpPr>
+          <p:cNvPr id="6" name="TextBox 5"/>
           <p:cNvSpPr txBox="1"/>
           <p:nvPr/>
         </p:nvSpPr>
         <p:spPr>
           <a:xfrm>
-            <a:off x="6949440" y="3822192"/>
-            <a:ext cx="2148840" cy="1188720"/>
+            <a:off x="685800" y="4114800"/>
+            <a:ext cx="10820095" cy="2194560"/>
           </a:xfrm>
           <a:prstGeom prst="rect">
             <a:avLst/>
@@ -6048,188 +5627,98 @@
           </a:bodyPr>
           <a:lstStyle/>
           <a:p>
-            <a:pPr algn="ctr">
-              <a:spcBef>
-                <a:spcPts val="0"/>
-              </a:spcBef>
-              <a:spcAft>
-                <a:spcPts val="200"/>
-              </a:spcAft>
-            </a:pPr>
-            <a:r>
-              <a:rPr sz="4000" b="1" i="0">
-                <a:solidFill>
-                  <a:srgbClr val="B3352C"/>
-                </a:solidFill>
-                <a:latin typeface="Segoe UI"/>
-              </a:rPr>
-              <a:t>159</a:t>
-            </a:r>
-          </a:p>
-          <a:p>
-            <a:pPr algn="ctr">
-              <a:spcBef>
-                <a:spcPts val="0"/>
-              </a:spcBef>
-              <a:spcAft>
-                <a:spcPts val="0"/>
-              </a:spcAft>
-            </a:pPr>
-            <a:r>
-              <a:rPr sz="1300" b="0" i="0">
-                <a:solidFill>
-                  <a:srgbClr val="5A6472"/>
-                </a:solidFill>
-                <a:latin typeface="Segoe UI"/>
-              </a:rPr>
-              <a:t>useless data points</a:t>
-            </a:r>
-          </a:p>
-        </p:txBody>
-      </p:sp>
-      <p:sp>
-        <p:nvSpPr>
-          <p:cNvPr id="9" name="Rectangle 8"/>
-          <p:cNvSpPr/>
-          <p:nvPr/>
-        </p:nvSpPr>
-        <p:spPr>
-          <a:xfrm>
-            <a:off x="9372600" y="3657600"/>
-            <a:ext cx="2148840" cy="1508760"/>
-          </a:xfrm>
-          <a:prstGeom prst="rect">
-            <a:avLst/>
-          </a:prstGeom>
-          <a:solidFill>
-            <a:srgbClr val="F2F5F9"/>
-          </a:solidFill>
-          <a:ln>
-            <a:noFill/>
-          </a:ln>
-          <a:effectLst/>
-        </p:spPr>
-        <p:style>
-          <a:lnRef idx="1">
-            <a:schemeClr val="accent1"/>
-          </a:lnRef>
-          <a:fillRef idx="3">
-            <a:schemeClr val="accent1"/>
-          </a:fillRef>
-          <a:effectRef idx="2">
-            <a:schemeClr val="accent1"/>
-          </a:effectRef>
-          <a:fontRef idx="minor">
-            <a:schemeClr val="lt1"/>
-          </a:fontRef>
-        </p:style>
-        <p:txBody>
-          <a:bodyPr rtlCol="0" anchor="ctr"/>
-          <a:lstStyle/>
-          <a:p>
-            <a:pPr algn="ctr"/>
-          </a:p>
-        </p:txBody>
-      </p:sp>
-      <p:sp>
-        <p:nvSpPr>
-          <p:cNvPr id="10" name="TextBox 9"/>
-          <p:cNvSpPr txBox="1"/>
-          <p:nvPr/>
-        </p:nvSpPr>
-        <p:spPr>
-          <a:xfrm>
-            <a:off x="9372600" y="3822192"/>
-            <a:ext cx="2148840" cy="1188720"/>
-          </a:xfrm>
-          <a:prstGeom prst="rect">
-            <a:avLst/>
-          </a:prstGeom>
-          <a:noFill/>
-        </p:spPr>
-        <p:txBody>
-          <a:bodyPr wrap="square">
-            <a:spAutoFit/>
-          </a:bodyPr>
-          <a:lstStyle/>
-          <a:p>
-            <a:pPr algn="ctr">
-              <a:spcBef>
-                <a:spcPts val="0"/>
-              </a:spcBef>
-              <a:spcAft>
-                <a:spcPts val="200"/>
-              </a:spcAft>
-            </a:pPr>
-            <a:r>
-              <a:rPr sz="2600" b="1" i="0">
-                <a:solidFill>
-                  <a:srgbClr val="1A7F4B"/>
-                </a:solidFill>
-                <a:latin typeface="Segoe UI"/>
-              </a:rPr>
-              <a:t>44% → 85%</a:t>
-            </a:r>
-          </a:p>
-          <a:p>
-            <a:pPr algn="ctr">
-              <a:spcBef>
-                <a:spcPts val="0"/>
-              </a:spcBef>
-              <a:spcAft>
-                <a:spcPts val="0"/>
-              </a:spcAft>
-            </a:pPr>
-            <a:r>
-              <a:rPr sz="1300" b="0" i="0">
-                <a:solidFill>
-                  <a:srgbClr val="5A6472"/>
-                </a:solidFill>
-                <a:latin typeface="Segoe UI"/>
-              </a:rPr>
-              <a:t>true score, once fixed</a:t>
-            </a:r>
-          </a:p>
-        </p:txBody>
-      </p:sp>
-      <p:sp>
-        <p:nvSpPr>
-          <p:cNvPr id="11" name="TextBox 10"/>
-          <p:cNvSpPr txBox="1"/>
-          <p:nvPr/>
-        </p:nvSpPr>
-        <p:spPr>
-          <a:xfrm>
-            <a:off x="685800" y="5943600"/>
-            <a:ext cx="10820095" cy="502920"/>
-          </a:xfrm>
-          <a:prstGeom prst="rect">
-            <a:avLst/>
-          </a:prstGeom>
-          <a:noFill/>
-        </p:spPr>
-        <p:txBody>
-          <a:bodyPr wrap="square">
-            <a:spAutoFit/>
-          </a:bodyPr>
-          <a:lstStyle/>
-          <a:p>
-            <a:pPr algn="l">
-              <a:spcBef>
-                <a:spcPts val="0"/>
-              </a:spcBef>
-              <a:spcAft>
-                <a:spcPts val="600"/>
-              </a:spcAft>
-            </a:pPr>
-            <a:r>
-              <a:rPr sz="1500" b="0" i="1">
-                <a:solidFill>
-                  <a:srgbClr val="5A6472"/>
-                </a:solidFill>
-                <a:latin typeface="Segoe UI"/>
-              </a:rPr>
-              <a:t>A metric returning a plausible constant is more dangerous than one that crashes.</a:t>
+            <a:pPr algn="l">
+              <a:spcBef>
+                <a:spcPts val="0"/>
+              </a:spcBef>
+              <a:spcAft>
+                <a:spcPts val="1300"/>
+              </a:spcAft>
+            </a:pPr>
+            <a:r>
+              <a:rPr sz="1700" b="1" i="0">
+                <a:solidFill>
+                  <a:srgbClr val="1A1D24"/>
+                </a:solidFill>
+                <a:latin typeface="Segoe UI"/>
+              </a:rPr>
+              <a:t>The final model lost to the model it started from.</a:t>
+            </a:r>
+          </a:p>
+          <a:p>
+            <a:pPr algn="l">
+              <a:spcBef>
+                <a:spcPts val="0"/>
+              </a:spcBef>
+              <a:spcAft>
+                <a:spcPts val="1300"/>
+              </a:spcAft>
+            </a:pPr>
+            <a:r>
+              <a:rPr sz="1700" b="0" i="0">
+                <a:solidFill>
+                  <a:srgbClr val="1A1D24"/>
+                </a:solidFill>
+                <a:latin typeface="Segoe UI"/>
+              </a:rPr>
+              <a:t>Hours of compute made it measurably weaker — while the loss curve fell the entire time.</a:t>
+            </a:r>
+          </a:p>
+          <a:p>
+            <a:pPr algn="l">
+              <a:spcBef>
+                <a:spcPts val="0"/>
+              </a:spcBef>
+              <a:spcAft>
+                <a:spcPts val="1300"/>
+              </a:spcAft>
+            </a:pPr>
+            <a:r>
+              <a:rPr sz="1700" b="1" i="0">
+                <a:solidFill>
+                  <a:srgbClr val="1F4E9C"/>
+                </a:solidFill>
+                <a:latin typeface="Segoe UI"/>
+              </a:rPr>
+              <a:t>Why the loss is not a strength signal:</a:t>
+            </a:r>
+          </a:p>
+          <a:p>
+            <a:pPr algn="l">
+              <a:spcBef>
+                <a:spcPts val="0"/>
+              </a:spcBef>
+              <a:spcAft>
+                <a:spcPts val="1300"/>
+              </a:spcAft>
+            </a:pPr>
+            <a:r>
+              <a:rPr sz="1700" b="0" i="0">
+                <a:solidFill>
+                  <a:srgbClr val="1A1D24"/>
+                </a:solidFill>
+                <a:latin typeface="Segoe UI"/>
+              </a:rPr>
+              <a:t>The loss is computed against targets the model generated itself. Minimising it proves the model agrees with itself. It says nothing about whether it plays better chess.</a:t>
+            </a:r>
+          </a:p>
+          <a:p>
+            <a:pPr algn="l">
+              <a:spcBef>
+                <a:spcPts val="0"/>
+              </a:spcBef>
+              <a:spcAft>
+                <a:spcPts val="1300"/>
+              </a:spcAft>
+            </a:pPr>
+            <a:r>
+              <a:rPr sz="1700" b="0" i="0">
+                <a:solidFill>
+                  <a:srgbClr val="1A1D24"/>
+                </a:solidFill>
+                <a:latin typeface="Segoe UI"/>
+              </a:rPr>
+              <a:t>Every self-training and self-supervised pipeline shares this structure — and therefore this failure mode.</a:t>
             </a:r>
           </a:p>
         </p:txBody>
@@ -6297,7 +5786,7 @@
                 </a:solidFill>
                 <a:latin typeface="Segoe UI"/>
               </a:rPr>
-              <a:t>THE REAL RESULT</a:t>
+              <a:t>DIAGNOSIS</a:t>
             </a:r>
           </a:p>
           <a:p>
@@ -6312,11 +5801,11 @@
             <a:r>
               <a:rPr sz="3300" b="1" i="0">
                 <a:solidFill>
-                  <a:srgbClr val="B3352C"/>
-                </a:solidFill>
-                <a:latin typeface="Segoe UI"/>
-              </a:rPr>
-              <a:t>Self-play made the model worse</a:t>
+                  <a:srgbClr val="1A1D24"/>
+                </a:solidFill>
+                <a:latin typeface="Segoe UI"/>
+              </a:rPr>
+              <a:t>Two root causes, isolated by experiment</a:t>
             </a:r>
           </a:p>
         </p:txBody>
@@ -6365,50 +5854,30 @@
           </a:p>
         </p:txBody>
       </p:sp>
-      <p:sp>
-        <p:nvSpPr>
-          <p:cNvPr id="4" name="Rectangle 3"/>
-          <p:cNvSpPr/>
+      <p:pic>
+        <p:nvPicPr>
+          <p:cNvPr id="4" name="Picture 3" descr="sims_scaling.png"/>
+          <p:cNvPicPr>
+            <a:picLocks noChangeAspect="1"/>
+          </p:cNvPicPr>
           <p:nvPr/>
-        </p:nvSpPr>
-        <p:spPr>
-          <a:xfrm>
-            <a:off x="685800" y="2103120"/>
-            <a:ext cx="10820095" cy="1737360"/>
+        </p:nvPicPr>
+        <p:blipFill>
+          <a:blip r:embed="rId2"/>
+          <a:stretch>
+            <a:fillRect/>
+          </a:stretch>
+        </p:blipFill>
+        <p:spPr>
+          <a:xfrm>
+            <a:off x="685800" y="2057400"/>
+            <a:ext cx="5120640" cy="4235881"/>
           </a:xfrm>
           <a:prstGeom prst="rect">
             <a:avLst/>
           </a:prstGeom>
-          <a:solidFill>
-            <a:srgbClr val="FBF0EF"/>
-          </a:solidFill>
-          <a:ln>
-            <a:noFill/>
-          </a:ln>
-          <a:effectLst/>
-        </p:spPr>
-        <p:style>
-          <a:lnRef idx="1">
-            <a:schemeClr val="accent1"/>
-          </a:lnRef>
-          <a:fillRef idx="3">
-            <a:schemeClr val="accent1"/>
-          </a:fillRef>
-          <a:effectRef idx="2">
-            <a:schemeClr val="accent1"/>
-          </a:effectRef>
-          <a:fontRef idx="minor">
-            <a:schemeClr val="lt1"/>
-          </a:fontRef>
-        </p:style>
-        <p:txBody>
-          <a:bodyPr rtlCol="0" anchor="ctr"/>
-          <a:lstStyle/>
-          <a:p>
-            <a:pPr algn="ctr"/>
-          </a:p>
-        </p:txBody>
-      </p:sp>
+        </p:spPr>
+      </p:pic>
       <p:sp>
         <p:nvSpPr>
           <p:cNvPr id="5" name="TextBox 4"/>
@@ -6417,8 +5886,8 @@
         </p:nvSpPr>
         <p:spPr>
           <a:xfrm>
-            <a:off x="685800" y="2331720"/>
-            <a:ext cx="10820095" cy="1371600"/>
+            <a:off x="5943600" y="2011680"/>
+            <a:ext cx="5577840" cy="4297680"/>
           </a:xfrm>
           <a:prstGeom prst="rect">
             <a:avLst/>
@@ -6431,66 +5900,100 @@
           </a:bodyPr>
           <a:lstStyle/>
           <a:p>
-            <a:pPr algn="ctr">
-              <a:spcBef>
-                <a:spcPts val="0"/>
-              </a:spcBef>
-              <a:spcAft>
-                <a:spcPts val="600"/>
-              </a:spcAft>
-            </a:pPr>
-            <a:r>
-              <a:rPr sz="4000" b="1" i="0">
+            <a:pPr algn="l">
+              <a:spcBef>
+                <a:spcPts val="0"/>
+              </a:spcBef>
+              <a:spcAft>
+                <a:spcPts val="1300"/>
+              </a:spcAft>
+            </a:pPr>
+            <a:r>
+              <a:rPr sz="1500" b="1" i="0">
+                <a:solidFill>
+                  <a:srgbClr val="1F4E9C"/>
+                </a:solidFill>
+                <a:latin typeface="Segoe UI"/>
+              </a:rPr>
+              <a:t>1 · The targets were noise</a:t>
+            </a:r>
+          </a:p>
+          <a:p>
+            <a:pPr algn="l">
+              <a:spcBef>
+                <a:spcPts val="0"/>
+              </a:spcBef>
+              <a:spcAft>
+                <a:spcPts val="1300"/>
+              </a:spcAft>
+            </a:pPr>
+            <a:r>
+              <a:rPr sz="1500" b="0" i="0">
+                <a:solidFill>
+                  <a:srgbClr val="1A1D24"/>
+                </a:solidFill>
+                <a:latin typeface="Segoe UI"/>
+              </a:rPr>
+              <a:t>Search is not weak — MCTS beats the raw policy 79% at 40 simulations. But 40 simulations over ~30 legal moves is 1.3 visits per move.</a:t>
+            </a:r>
+          </a:p>
+          <a:p>
+            <a:pPr algn="l">
+              <a:spcBef>
+                <a:spcPts val="0"/>
+              </a:spcBef>
+              <a:spcAft>
+                <a:spcPts val="1300"/>
+              </a:spcAft>
+            </a:pPr>
+            <a:r>
+              <a:rPr sz="1500" b="0" i="0">
+                <a:solidFill>
+                  <a:srgbClr val="1A1D24"/>
+                </a:solidFill>
+                <a:latin typeface="Segoe UI"/>
+              </a:rPr>
+              <a:t>The best move is good; the distribution is sampling noise — and the loss trains on the distribution.</a:t>
+            </a:r>
+          </a:p>
+          <a:p>
+            <a:pPr algn="l">
+              <a:spcBef>
+                <a:spcPts val="0"/>
+              </a:spcBef>
+              <a:spcAft>
+                <a:spcPts val="1300"/>
+              </a:spcAft>
+            </a:pPr>
+            <a:r>
+              <a:rPr sz="1500" b="1" i="0">
                 <a:solidFill>
                   <a:srgbClr val="B3352C"/>
                 </a:solidFill>
                 <a:latin typeface="Segoe UI"/>
               </a:rPr>
-              <a:t>v5 final   2.5  —  5.5   its own starting point</a:t>
-            </a:r>
-          </a:p>
-          <a:p>
-            <a:pPr algn="ctr">
-              <a:spcBef>
-                <a:spcPts val="0"/>
-              </a:spcBef>
-              <a:spcAft>
-                <a:spcPts val="0"/>
+              <a:t>2 · The augmentation was illegal</a:t>
+            </a:r>
+          </a:p>
+          <a:p>
+            <a:pPr algn="l">
+              <a:spcBef>
+                <a:spcPts val="0"/>
+              </a:spcBef>
+              <a:spcAft>
+                <a:spcPts val="1300"/>
               </a:spcAft>
             </a:pPr>
             <a:r>
               <a:rPr sz="1500" b="0" i="0">
                 <a:solidFill>
-                  <a:srgbClr val="5A6472"/>
-                </a:solidFill>
-                <a:latin typeface="Segoe UI"/>
-              </a:rPr>
-              <a:t>8 games, alternating colours, randomised openings</a:t>
-            </a:r>
-          </a:p>
-        </p:txBody>
-      </p:sp>
-      <p:sp>
-        <p:nvSpPr>
-          <p:cNvPr id="6" name="TextBox 5"/>
-          <p:cNvSpPr txBox="1"/>
-          <p:nvPr/>
-        </p:nvSpPr>
-        <p:spPr>
-          <a:xfrm>
-            <a:off x="685800" y="4114800"/>
-            <a:ext cx="10820095" cy="2194560"/>
-          </a:xfrm>
-          <a:prstGeom prst="rect">
-            <a:avLst/>
-          </a:prstGeom>
-          <a:noFill/>
-        </p:spPr>
-        <p:txBody>
-          <a:bodyPr wrap="square">
-            <a:spAutoFit/>
-          </a:bodyPr>
-          <a:lstStyle/>
+                  <a:srgbClr val="1A1D24"/>
+                </a:solidFill>
+                <a:latin typeface="Segoe UI"/>
+              </a:rPr>
+              <a:t>Mirroring flipped board files but never swapped the castling planes. The king lands on d1 with “kingside castling” still set — a position that cannot exist in chess.</a:t>
+            </a:r>
+          </a:p>
           <a:p>
             <a:pPr algn="l">
               <a:spcBef>
@@ -6501,89 +6004,13 @@
               </a:spcAft>
             </a:pPr>
             <a:r>
-              <a:rPr sz="1700" b="1" i="0">
-                <a:solidFill>
-                  <a:srgbClr val="1A1D24"/>
-                </a:solidFill>
-                <a:latin typeface="Segoe UI"/>
-              </a:rPr>
-              <a:t>The final model lost to the model it started from.</a:t>
-            </a:r>
-          </a:p>
-          <a:p>
-            <a:pPr algn="l">
-              <a:spcBef>
-                <a:spcPts val="0"/>
-              </a:spcBef>
-              <a:spcAft>
-                <a:spcPts val="1300"/>
-              </a:spcAft>
-            </a:pPr>
-            <a:r>
-              <a:rPr sz="1700" b="0" i="0">
-                <a:solidFill>
-                  <a:srgbClr val="1A1D24"/>
-                </a:solidFill>
-                <a:latin typeface="Segoe UI"/>
-              </a:rPr>
-              <a:t>Hours of compute made it measurably weaker — while the loss curve fell the entire time.</a:t>
-            </a:r>
-          </a:p>
-          <a:p>
-            <a:pPr algn="l">
-              <a:spcBef>
-                <a:spcPts val="0"/>
-              </a:spcBef>
-              <a:spcAft>
-                <a:spcPts val="1300"/>
-              </a:spcAft>
-            </a:pPr>
-            <a:r>
-              <a:rPr sz="1700" b="1" i="0">
-                <a:solidFill>
-                  <a:srgbClr val="1F4E9C"/>
-                </a:solidFill>
-                <a:latin typeface="Segoe UI"/>
-              </a:rPr>
-              <a:t>Why the loss is not a strength signal:</a:t>
-            </a:r>
-          </a:p>
-          <a:p>
-            <a:pPr algn="l">
-              <a:spcBef>
-                <a:spcPts val="0"/>
-              </a:spcBef>
-              <a:spcAft>
-                <a:spcPts val="1300"/>
-              </a:spcAft>
-            </a:pPr>
-            <a:r>
-              <a:rPr sz="1700" b="0" i="0">
-                <a:solidFill>
-                  <a:srgbClr val="1A1D24"/>
-                </a:solidFill>
-                <a:latin typeface="Segoe UI"/>
-              </a:rPr>
-              <a:t>The loss is computed against targets the model generated itself. Minimising it proves the model agrees with itself. It says nothing about whether it plays better chess.</a:t>
-            </a:r>
-          </a:p>
-          <a:p>
-            <a:pPr algn="l">
-              <a:spcBef>
-                <a:spcPts val="0"/>
-              </a:spcBef>
-              <a:spcAft>
-                <a:spcPts val="1300"/>
-              </a:spcAft>
-            </a:pPr>
-            <a:r>
-              <a:rPr sz="1700" b="0" i="0">
-                <a:solidFill>
-                  <a:srgbClr val="1A1D24"/>
-                </a:solidFill>
-                <a:latin typeface="Segoe UI"/>
-              </a:rPr>
-              <a:t>Every self-training and self-supervised pipeline shares this structure — and therefore this failure mode.</a:t>
+              <a:rPr sz="1500" b="1" i="0">
+                <a:solidFill>
+                  <a:srgbClr val="B3352C"/>
+                </a:solidFill>
+                <a:latin typeface="Segoe UI"/>
+              </a:rPr>
+              <a:t>~50% of every training batch was corrupted.</a:t>
             </a:r>
           </a:p>
         </p:txBody>
@@ -6651,7 +6078,7 @@
                 </a:solidFill>
                 <a:latin typeface="Segoe UI"/>
               </a:rPr>
-              <a:t>DIAGNOSIS</a:t>
+              <a:t>THE FIX</a:t>
             </a:r>
           </a:p>
           <a:p>
@@ -6666,11 +6093,11 @@
             <a:r>
               <a:rPr sz="3300" b="1" i="0">
                 <a:solidFill>
-                  <a:srgbClr val="1A1D24"/>
-                </a:solidFill>
-                <a:latin typeface="Segoe UI"/>
-              </a:rPr>
-              <a:t>Two root causes, isolated by experiment</a:t>
+                  <a:srgbClr val="1A7F4B"/>
+                </a:solidFill>
+                <a:latin typeface="Segoe UI"/>
+              </a:rPr>
+              <a:t>Gating stopped the bleeding</a:t>
             </a:r>
           </a:p>
         </p:txBody>
@@ -6719,40 +6146,16 @@
           </a:p>
         </p:txBody>
       </p:sp>
-      <p:pic>
-        <p:nvPicPr>
-          <p:cNvPr id="4" name="Picture 3" descr="sims_scaling.png"/>
-          <p:cNvPicPr>
-            <a:picLocks noChangeAspect="1"/>
-          </p:cNvPicPr>
-          <p:nvPr/>
-        </p:nvPicPr>
-        <p:blipFill>
-          <a:blip r:embed="rId2"/>
-          <a:stretch>
-            <a:fillRect/>
-          </a:stretch>
-        </p:blipFill>
-        <p:spPr>
-          <a:xfrm>
-            <a:off x="685800" y="2057400"/>
-            <a:ext cx="5120640" cy="4235881"/>
-          </a:xfrm>
-          <a:prstGeom prst="rect">
-            <a:avLst/>
-          </a:prstGeom>
-        </p:spPr>
-      </p:pic>
-      <p:sp>
-        <p:nvSpPr>
-          <p:cNvPr id="5" name="TextBox 4"/>
+      <p:sp>
+        <p:nvSpPr>
+          <p:cNvPr id="4" name="TextBox 3"/>
           <p:cNvSpPr txBox="1"/>
           <p:nvPr/>
         </p:nvSpPr>
         <p:spPr>
           <a:xfrm>
-            <a:off x="5943600" y="2011680"/>
-            <a:ext cx="5577840" cy="4297680"/>
+            <a:off x="685800" y="1920240"/>
+            <a:ext cx="6400800" cy="4389120"/>
           </a:xfrm>
           <a:prstGeom prst="rect">
             <a:avLst/>
@@ -6774,13 +6177,13 @@
               </a:spcAft>
             </a:pPr>
             <a:r>
-              <a:rPr sz="1500" b="1" i="0">
-                <a:solidFill>
-                  <a:srgbClr val="1F4E9C"/>
-                </a:solidFill>
-                <a:latin typeface="Segoe UI"/>
-              </a:rPr>
-              <a:t>1 · The targets were noise</a:t>
+              <a:rPr sz="1600" b="1" i="0">
+                <a:solidFill>
+                  <a:srgbClr val="1A7F4B"/>
+                </a:solidFill>
+                <a:latin typeface="Segoe UI"/>
+              </a:rPr>
+              <a:t>Acceptance gating, from AlphaGo Zero</a:t>
             </a:r>
           </a:p>
           <a:p>
@@ -6793,13 +6196,13 @@
               </a:spcAft>
             </a:pPr>
             <a:r>
-              <a:rPr sz="1500" b="0" i="0">
+              <a:rPr sz="1600" b="0" i="0">
                 <a:solidFill>
                   <a:srgbClr val="1A1D24"/>
                 </a:solidFill>
                 <a:latin typeface="Segoe UI"/>
               </a:rPr>
-              <a:t>Search is not weak — MCTS beats the raw policy 79% at 40 simulations. But 40 simulations over ~30 legal moves is 1.3 visits per move.</a:t>
+              <a:t>Self-play always generates from the best weights so far; new weights are promoted only after scoring ≥ 55% against the incumbent.</a:t>
             </a:r>
           </a:p>
           <a:p>
@@ -6812,13 +6215,13 @@
               </a:spcAft>
             </a:pPr>
             <a:r>
-              <a:rPr sz="1500" b="0" i="0">
+              <a:rPr sz="1600" b="0" i="0">
                 <a:solidFill>
                   <a:srgbClr val="1A1D24"/>
                 </a:solidFill>
                 <a:latin typeface="Segoe UI"/>
               </a:rPr>
-              <a:t>The best move is good; the distribution is sampling noise — and the loss trains on the distribution.</a:t>
+              <a:t>Plus castling-aware augmentation, 128 simulations instead of 40, 80 gradient steps instead of 200.</a:t>
             </a:r>
           </a:p>
           <a:p>
@@ -6831,51 +6234,297 @@
               </a:spcAft>
             </a:pPr>
             <a:r>
-              <a:rPr sz="1500" b="1" i="0">
+              <a:rPr sz="1600" b="1" i="0">
+                <a:solidFill>
+                  <a:srgbClr val="1A7F4B"/>
+                </a:solidFill>
+                <a:latin typeface="Segoe UI"/>
+              </a:rPr>
+              <a:t>199 iterations later — no regression.</a:t>
+            </a:r>
+          </a:p>
+          <a:p>
+            <a:pPr algn="l">
+              <a:spcBef>
+                <a:spcPts val="0"/>
+              </a:spcBef>
+              <a:spcAft>
+                <a:spcPts val="1300"/>
+              </a:spcAft>
+            </a:pPr>
+            <a:r>
+              <a:rPr sz="1600" b="0" i="0">
+                <a:solidFill>
+                  <a:srgbClr val="1A1D24"/>
+                </a:solidFill>
+                <a:latin typeface="Segoe UI"/>
+              </a:rPr>
+              <a:t>The candidates the gate rejected averaged 42.2% vs baseline (p = 0.004): self-play was still degrading the network.</a:t>
+            </a:r>
+          </a:p>
+          <a:p>
+            <a:pPr algn="l">
+              <a:spcBef>
+                <a:spcPts val="0"/>
+              </a:spcBef>
+              <a:spcAft>
+                <a:spcPts val="1300"/>
+              </a:spcAft>
+            </a:pPr>
+            <a:r>
+              <a:rPr sz="1600" b="0" i="0">
+                <a:solidFill>
+                  <a:srgbClr val="1A1D24"/>
+                </a:solidFill>
+                <a:latin typeface="Segoe UI"/>
+              </a:rPr>
+              <a:t>The gate kept that damage out of the deployed model.</a:t>
+            </a:r>
+          </a:p>
+        </p:txBody>
+      </p:sp>
+      <p:sp>
+        <p:nvSpPr>
+          <p:cNvPr id="5" name="Rectangle 4"/>
+          <p:cNvSpPr/>
+          <p:nvPr/>
+        </p:nvSpPr>
+        <p:spPr>
+          <a:xfrm>
+            <a:off x="7498079" y="2194560"/>
+            <a:ext cx="4023360" cy="1097280"/>
+          </a:xfrm>
+          <a:prstGeom prst="rect">
+            <a:avLst/>
+          </a:prstGeom>
+          <a:solidFill>
+            <a:srgbClr val="F7F7F4"/>
+          </a:solidFill>
+          <a:ln>
+            <a:noFill/>
+          </a:ln>
+          <a:effectLst/>
+        </p:spPr>
+        <p:style>
+          <a:lnRef idx="1">
+            <a:schemeClr val="accent1"/>
+          </a:lnRef>
+          <a:fillRef idx="3">
+            <a:schemeClr val="accent1"/>
+          </a:fillRef>
+          <a:effectRef idx="2">
+            <a:schemeClr val="accent1"/>
+          </a:effectRef>
+          <a:fontRef idx="minor">
+            <a:schemeClr val="lt1"/>
+          </a:fontRef>
+        </p:style>
+        <p:txBody>
+          <a:bodyPr rtlCol="0" anchor="ctr"/>
+          <a:lstStyle/>
+          <a:p>
+            <a:pPr algn="ctr"/>
+          </a:p>
+        </p:txBody>
+      </p:sp>
+      <p:sp>
+        <p:nvSpPr>
+          <p:cNvPr id="6" name="TextBox 5"/>
+          <p:cNvSpPr txBox="1"/>
+          <p:nvPr/>
+        </p:nvSpPr>
+        <p:spPr>
+          <a:xfrm>
+            <a:off x="7699247" y="2340864"/>
+            <a:ext cx="3657600" cy="1097280"/>
+          </a:xfrm>
+          <a:prstGeom prst="rect">
+            <a:avLst/>
+          </a:prstGeom>
+          <a:noFill/>
+        </p:spPr>
+        <p:txBody>
+          <a:bodyPr wrap="square">
+            <a:spAutoFit/>
+          </a:bodyPr>
+          <a:lstStyle/>
+          <a:p>
+            <a:pPr>
+              <a:spcAft>
+                <a:spcPts val="500"/>
+              </a:spcAft>
+            </a:pPr>
+            <a:r>
+              <a:rPr sz="1500">
+                <a:solidFill>
+                  <a:srgbClr val="1A1D24"/>
+                </a:solidFill>
+                <a:latin typeface="Consolas"/>
+              </a:rPr>
+              <a:t>gate: candidate 43.8%</a:t>
+            </a:r>
+          </a:p>
+          <a:p>
+            <a:pPr>
+              <a:spcAft>
+                <a:spcPts val="500"/>
+              </a:spcAft>
+            </a:pPr>
+            <a:r>
+              <a:rPr sz="1500">
                 <a:solidFill>
                   <a:srgbClr val="B3352C"/>
                 </a:solidFill>
-                <a:latin typeface="Segoe UI"/>
-              </a:rPr>
-              <a:t>2 · The augmentation was illegal</a:t>
-            </a:r>
-          </a:p>
-          <a:p>
-            <a:pPr algn="l">
-              <a:spcBef>
-                <a:spcPts val="0"/>
-              </a:spcBef>
-              <a:spcAft>
-                <a:spcPts val="1300"/>
-              </a:spcAft>
-            </a:pPr>
-            <a:r>
-              <a:rPr sz="1500" b="0" i="0">
-                <a:solidFill>
-                  <a:srgbClr val="1A1D24"/>
-                </a:solidFill>
-                <a:latin typeface="Segoe UI"/>
-              </a:rPr>
-              <a:t>Mirroring flipped board files but never swapped the castling planes. The king lands on d1 with “kingside castling” still set — a position that cannot exist in chess.</a:t>
-            </a:r>
-          </a:p>
-          <a:p>
-            <a:pPr algn="l">
-              <a:spcBef>
-                <a:spcPts val="0"/>
-              </a:spcBef>
-              <a:spcAft>
-                <a:spcPts val="1300"/>
-              </a:spcAft>
-            </a:pPr>
-            <a:r>
-              <a:rPr sz="1500" b="1" i="0">
-                <a:solidFill>
-                  <a:srgbClr val="B3352C"/>
-                </a:solidFill>
-                <a:latin typeface="Segoe UI"/>
-              </a:rPr>
-              <a:t>~50% of every training batch was corrupted.</a:t>
+                <a:latin typeface="Consolas"/>
+              </a:rPr>
+              <a:t>      vs best -&gt; rejected</a:t>
+            </a:r>
+          </a:p>
+        </p:txBody>
+      </p:sp>
+      <p:sp>
+        <p:nvSpPr>
+          <p:cNvPr id="7" name="Rectangle 6"/>
+          <p:cNvSpPr/>
+          <p:nvPr/>
+        </p:nvSpPr>
+        <p:spPr>
+          <a:xfrm>
+            <a:off x="7498079" y="3657600"/>
+            <a:ext cx="4023360" cy="1508760"/>
+          </a:xfrm>
+          <a:prstGeom prst="rect">
+            <a:avLst/>
+          </a:prstGeom>
+          <a:solidFill>
+            <a:srgbClr val="F2F5F9"/>
+          </a:solidFill>
+          <a:ln>
+            <a:noFill/>
+          </a:ln>
+          <a:effectLst/>
+        </p:spPr>
+        <p:style>
+          <a:lnRef idx="1">
+            <a:schemeClr val="accent1"/>
+          </a:lnRef>
+          <a:fillRef idx="3">
+            <a:schemeClr val="accent1"/>
+          </a:fillRef>
+          <a:effectRef idx="2">
+            <a:schemeClr val="accent1"/>
+          </a:effectRef>
+          <a:fontRef idx="minor">
+            <a:schemeClr val="lt1"/>
+          </a:fontRef>
+        </p:style>
+        <p:txBody>
+          <a:bodyPr rtlCol="0" anchor="ctr"/>
+          <a:lstStyle/>
+          <a:p>
+            <a:pPr algn="ctr"/>
+          </a:p>
+        </p:txBody>
+      </p:sp>
+      <p:sp>
+        <p:nvSpPr>
+          <p:cNvPr id="8" name="TextBox 7"/>
+          <p:cNvSpPr txBox="1"/>
+          <p:nvPr/>
+        </p:nvSpPr>
+        <p:spPr>
+          <a:xfrm>
+            <a:off x="7498079" y="3822192"/>
+            <a:ext cx="4023360" cy="1188720"/>
+          </a:xfrm>
+          <a:prstGeom prst="rect">
+            <a:avLst/>
+          </a:prstGeom>
+          <a:noFill/>
+        </p:spPr>
+        <p:txBody>
+          <a:bodyPr wrap="square">
+            <a:spAutoFit/>
+          </a:bodyPr>
+          <a:lstStyle/>
+          <a:p>
+            <a:pPr algn="ctr">
+              <a:spcBef>
+                <a:spcPts val="0"/>
+              </a:spcBef>
+              <a:spcAft>
+                <a:spcPts val="200"/>
+              </a:spcAft>
+            </a:pPr>
+            <a:r>
+              <a:rPr sz="3800" b="1" i="0">
+                <a:solidFill>
+                  <a:srgbClr val="1A7F4B"/>
+                </a:solidFill>
+                <a:latin typeface="Segoe UI"/>
+              </a:rPr>
+              <a:t>46.2%</a:t>
+            </a:r>
+          </a:p>
+          <a:p>
+            <a:pPr algn="ctr">
+              <a:spcBef>
+                <a:spcPts val="0"/>
+              </a:spcBef>
+              <a:spcAft>
+                <a:spcPts val="0"/>
+              </a:spcAft>
+            </a:pPr>
+            <a:r>
+              <a:rPr sz="1300" b="0" i="0">
+                <a:solidFill>
+                  <a:srgbClr val="5A6472"/>
+                </a:solidFill>
+                <a:latin typeface="Segoe UI"/>
+              </a:rPr>
+              <a:t>gated model vs its starting point — no detectable change</a:t>
+            </a:r>
+          </a:p>
+        </p:txBody>
+      </p:sp>
+      <p:sp>
+        <p:nvSpPr>
+          <p:cNvPr id="9" name="TextBox 8"/>
+          <p:cNvSpPr txBox="1"/>
+          <p:nvPr/>
+        </p:nvSpPr>
+        <p:spPr>
+          <a:xfrm>
+            <a:off x="685800" y="5943600"/>
+            <a:ext cx="10820095" cy="502920"/>
+          </a:xfrm>
+          <a:prstGeom prst="rect">
+            <a:avLst/>
+          </a:prstGeom>
+          <a:noFill/>
+        </p:spPr>
+        <p:txBody>
+          <a:bodyPr wrap="square">
+            <a:spAutoFit/>
+          </a:bodyPr>
+          <a:lstStyle/>
+          <a:p>
+            <a:pPr algn="l">
+              <a:spcBef>
+                <a:spcPts val="0"/>
+              </a:spcBef>
+              <a:spcAft>
+                <a:spcPts val="600"/>
+              </a:spcAft>
+            </a:pPr>
+            <a:r>
+              <a:rPr sz="1500" b="0" i="1">
+                <a:solidFill>
+                  <a:srgbClr val="5A6472"/>
+                </a:solidFill>
+                <a:latin typeface="Segoe UI"/>
+              </a:rPr>
+              <a:t>v5 without the fixes: 31.2%. Gating converted a real regression into no change.</a:t>
             </a:r>
           </a:p>
         </p:txBody>
@@ -6943,7 +6592,7 @@
                 </a:solidFill>
                 <a:latin typeface="Segoe UI"/>
               </a:rPr>
-              <a:t>THE FIX</a:t>
+              <a:t>WHAT I TAKE AWAY</a:t>
             </a:r>
           </a:p>
           <a:p>
@@ -6958,11 +6607,11 @@
             <a:r>
               <a:rPr sz="3300" b="1" i="0">
                 <a:solidFill>
-                  <a:srgbClr val="1A7F4B"/>
-                </a:solidFill>
-                <a:latin typeface="Segoe UI"/>
-              </a:rPr>
-              <a:t>Gating stopped the bleeding</a:t>
+                  <a:srgbClr val="1A1D24"/>
+                </a:solidFill>
+                <a:latin typeface="Segoe UI"/>
+              </a:rPr>
+              <a:t>Measurement is the hard part</a:t>
             </a:r>
           </a:p>
         </p:txBody>
@@ -7019,8 +6668,8 @@
         </p:nvSpPr>
         <p:spPr>
           <a:xfrm>
-            <a:off x="685800" y="1920240"/>
-            <a:ext cx="6400800" cy="4389120"/>
+            <a:off x="685800" y="1874519"/>
+            <a:ext cx="6949440" cy="4434841"/>
           </a:xfrm>
           <a:prstGeom prst="rect">
             <a:avLst/>
@@ -7044,11 +6693,11 @@
             <a:r>
               <a:rPr sz="1600" b="1" i="0">
                 <a:solidFill>
-                  <a:srgbClr val="1A7F4B"/>
-                </a:solidFill>
-                <a:latin typeface="Segoe UI"/>
-              </a:rPr>
-              <a:t>Acceptance gating, from AlphaGo Zero</a:t>
+                  <a:srgbClr val="1A1D24"/>
+                </a:solidFill>
+                <a:latin typeface="Segoe UI"/>
+              </a:rPr>
+              <a:t>A falling loss curve is not evidence that anything is working.</a:t>
             </a:r>
           </a:p>
           <a:p>
@@ -7067,7 +6716,7 @@
                 </a:solidFill>
                 <a:latin typeface="Segoe UI"/>
               </a:rPr>
-              <a:t>Self-play always generates from the best weights so far; new weights are promoted only after scoring ≥ 55% against the incumbent.</a:t>
+              <a:t>Especially when the model produces its own labels.</a:t>
             </a:r>
           </a:p>
           <a:p>
@@ -7080,13 +6729,32 @@
               </a:spcAft>
             </a:pPr>
             <a:r>
+              <a:rPr sz="1600" b="1" i="0">
+                <a:solidFill>
+                  <a:srgbClr val="1A1D24"/>
+                </a:solidFill>
+                <a:latin typeface="Segoe UI"/>
+              </a:rPr>
+              <a:t>Verify the metric before trusting the model.</a:t>
+            </a:r>
+          </a:p>
+          <a:p>
+            <a:pPr algn="l">
+              <a:spcBef>
+                <a:spcPts val="0"/>
+              </a:spcBef>
+              <a:spcAft>
+                <a:spcPts val="1300"/>
+              </a:spcAft>
+            </a:pPr>
+            <a:r>
               <a:rPr sz="1600" b="0" i="0">
                 <a:solidFill>
                   <a:srgbClr val="1A1D24"/>
                 </a:solidFill>
                 <a:latin typeface="Segoe UI"/>
               </a:rPr>
-              <a:t>Plus castling-aware augmentation, 128 simulations instead of 40, 80 gradient steps instead of 200.</a:t>
+              <a:t>Mine returned a plausible number 159 times in a row while measuring nothing at all.</a:t>
             </a:r>
           </a:p>
           <a:p>
@@ -7101,11 +6769,11 @@
             <a:r>
               <a:rPr sz="1600" b="1" i="0">
                 <a:solidFill>
-                  <a:srgbClr val="1A7F4B"/>
-                </a:solidFill>
-                <a:latin typeface="Segoe UI"/>
-              </a:rPr>
-              <a:t>199 iterations later — no regression.</a:t>
+                  <a:srgbClr val="1A1D24"/>
+                </a:solidFill>
+                <a:latin typeface="Segoe UI"/>
+              </a:rPr>
+              <a:t>Downscaling changes which statistic matters.</a:t>
             </a:r>
           </a:p>
           <a:p>
@@ -7124,7 +6792,7 @@
                 </a:solidFill>
                 <a:latin typeface="Segoe UI"/>
               </a:rPr>
-              <a:t>The candidates the gate rejected averaged 42.2% vs baseline (p = 0.004): self-play was still degrading the network.</a:t>
+              <a:t>800 → 40 simulations preserves the best move but destroys the distribution — and the loss reads the distribution.</a:t>
             </a:r>
           </a:p>
           <a:p>
@@ -7137,13 +6805,32 @@
               </a:spcAft>
             </a:pPr>
             <a:r>
+              <a:rPr sz="1600" b="1" i="0">
+                <a:solidFill>
+                  <a:srgbClr val="B3352C"/>
+                </a:solidFill>
+                <a:latin typeface="Segoe UI"/>
+              </a:rPr>
+              <a:t>Then audit the fix too.</a:t>
+            </a:r>
+          </a:p>
+          <a:p>
+            <a:pPr algn="l">
+              <a:spcBef>
+                <a:spcPts val="0"/>
+              </a:spcBef>
+              <a:spcAft>
+                <a:spcPts val="1300"/>
+              </a:spcAft>
+            </a:pPr>
+            <a:r>
               <a:rPr sz="1600" b="0" i="0">
                 <a:solidFill>
                   <a:srgbClr val="1A1D24"/>
                 </a:solidFill>
                 <a:latin typeface="Segoe UI"/>
               </a:rPr>
-              <a:t>The gate kept that damage out of the deployed model.</a:t>
+              <a:t>My gate promoted 8 of 20 candidates. Pure chance predicts 7.8 — an 8-game match could never have resolved this. The same mistake, one level up.</a:t>
             </a:r>
           </a:p>
         </p:txBody>
@@ -7156,14 +6843,14 @@
         </p:nvSpPr>
         <p:spPr>
           <a:xfrm>
-            <a:off x="7498079" y="2194560"/>
-            <a:ext cx="4023360" cy="1097280"/>
+            <a:off x="8138160" y="2103120"/>
+            <a:ext cx="3291840" cy="3108960"/>
           </a:xfrm>
           <a:prstGeom prst="rect">
             <a:avLst/>
           </a:prstGeom>
           <a:solidFill>
-            <a:srgbClr val="F7F7F4"/>
+            <a:srgbClr val="F2F5F9"/>
           </a:solidFill>
           <a:ln>
             <a:noFill/>
@@ -7200,8 +6887,8 @@
         </p:nvSpPr>
         <p:spPr>
           <a:xfrm>
-            <a:off x="7699247" y="2340864"/>
-            <a:ext cx="3657600" cy="1097280"/>
+            <a:off x="8366760" y="2331720"/>
+            <a:ext cx="2834640" cy="2743200"/>
           </a:xfrm>
           <a:prstGeom prst="rect">
             <a:avLst/>
@@ -7214,106 +6901,64 @@
           </a:bodyPr>
           <a:lstStyle/>
           <a:p>
-            <a:pPr>
-              <a:spcAft>
-                <a:spcPts val="500"/>
-              </a:spcAft>
-            </a:pPr>
-            <a:r>
-              <a:rPr sz="1500">
+            <a:pPr algn="l">
+              <a:spcBef>
+                <a:spcPts val="0"/>
+              </a:spcBef>
+              <a:spcAft>
+                <a:spcPts val="1200"/>
+              </a:spcAft>
+            </a:pPr>
+            <a:r>
+              <a:rPr sz="1700" b="1" i="0">
+                <a:solidFill>
+                  <a:srgbClr val="1F4E9C"/>
+                </a:solidFill>
+                <a:latin typeface="Segoe UI"/>
+              </a:rPr>
+              <a:t>Artifacts</a:t>
+            </a:r>
+          </a:p>
+          <a:p>
+            <a:pPr algn="l">
+              <a:spcBef>
+                <a:spcPts val="0"/>
+              </a:spcBef>
+              <a:spcAft>
+                <a:spcPts val="200"/>
+              </a:spcAft>
+            </a:pPr>
+            <a:r>
+              <a:rPr sz="1300" b="1" i="0">
+                <a:solidFill>
+                  <a:srgbClr val="5A6472"/>
+                </a:solidFill>
+                <a:latin typeface="Segoe UI"/>
+              </a:rPr>
+              <a:t>Code</a:t>
+            </a:r>
+          </a:p>
+          <a:p>
+            <a:pPr algn="l">
+              <a:spcBef>
+                <a:spcPts val="0"/>
+              </a:spcBef>
+              <a:spcAft>
+                <a:spcPts val="1200"/>
+              </a:spcAft>
+            </a:pPr>
+            <a:r>
+              <a:rPr sz="1200" b="0" i="0">
                 <a:solidFill>
                   <a:srgbClr val="1A1D24"/>
                 </a:solidFill>
-                <a:latin typeface="Consolas"/>
-              </a:rPr>
-              <a:t>gate: candidate 43.8%</a:t>
-            </a:r>
-          </a:p>
-          <a:p>
-            <a:pPr>
-              <a:spcAft>
-                <a:spcPts val="500"/>
-              </a:spcAft>
-            </a:pPr>
-            <a:r>
-              <a:rPr sz="1500">
-                <a:solidFill>
-                  <a:srgbClr val="B3352C"/>
-                </a:solidFill>
-                <a:latin typeface="Consolas"/>
-              </a:rPr>
-              <a:t>      vs best -&gt; rejected</a:t>
-            </a:r>
-          </a:p>
-        </p:txBody>
-      </p:sp>
-      <p:sp>
-        <p:nvSpPr>
-          <p:cNvPr id="7" name="Rectangle 6"/>
-          <p:cNvSpPr/>
-          <p:nvPr/>
-        </p:nvSpPr>
-        <p:spPr>
-          <a:xfrm>
-            <a:off x="7498079" y="3657600"/>
-            <a:ext cx="4023360" cy="1508760"/>
-          </a:xfrm>
-          <a:prstGeom prst="rect">
-            <a:avLst/>
-          </a:prstGeom>
-          <a:solidFill>
-            <a:srgbClr val="F2F5F9"/>
-          </a:solidFill>
-          <a:ln>
-            <a:noFill/>
-          </a:ln>
-          <a:effectLst/>
-        </p:spPr>
-        <p:style>
-          <a:lnRef idx="1">
-            <a:schemeClr val="accent1"/>
-          </a:lnRef>
-          <a:fillRef idx="3">
-            <a:schemeClr val="accent1"/>
-          </a:fillRef>
-          <a:effectRef idx="2">
-            <a:schemeClr val="accent1"/>
-          </a:effectRef>
-          <a:fontRef idx="minor">
-            <a:schemeClr val="lt1"/>
-          </a:fontRef>
-        </p:style>
-        <p:txBody>
-          <a:bodyPr rtlCol="0" anchor="ctr"/>
-          <a:lstStyle/>
-          <a:p>
-            <a:pPr algn="ctr"/>
-          </a:p>
-        </p:txBody>
-      </p:sp>
-      <p:sp>
-        <p:nvSpPr>
-          <p:cNvPr id="8" name="TextBox 7"/>
-          <p:cNvSpPr txBox="1"/>
-          <p:nvPr/>
-        </p:nvSpPr>
-        <p:spPr>
-          <a:xfrm>
-            <a:off x="7498079" y="3822192"/>
-            <a:ext cx="4023360" cy="1188720"/>
-          </a:xfrm>
-          <a:prstGeom prst="rect">
-            <a:avLst/>
-          </a:prstGeom>
-          <a:noFill/>
-        </p:spPr>
-        <p:txBody>
-          <a:bodyPr wrap="square">
-            <a:spAutoFit/>
-          </a:bodyPr>
-          <a:lstStyle/>
-          <a:p>
-            <a:pPr algn="ctr">
+                <a:latin typeface="Segoe UI"/>
+              </a:rPr>
+              <a:t>github.com/realgauravvyas/chess-ai</a:t>
+            </a:r>
+          </a:p>
+          <a:p>
+            <a:pPr algn="l">
               <a:spcBef>
                 <a:spcPts val="0"/>
               </a:spcBef>
@@ -7322,74 +6967,70 @@
               </a:spcAft>
             </a:pPr>
             <a:r>
-              <a:rPr sz="3800" b="1" i="0">
-                <a:solidFill>
-                  <a:srgbClr val="1A7F4B"/>
-                </a:solidFill>
-                <a:latin typeface="Segoe UI"/>
-              </a:rPr>
-              <a:t>46.2%</a:t>
-            </a:r>
-          </a:p>
-          <a:p>
-            <a:pPr algn="ctr">
-              <a:spcBef>
-                <a:spcPts val="0"/>
-              </a:spcBef>
-              <a:spcAft>
-                <a:spcPts val="0"/>
-              </a:spcAft>
-            </a:pPr>
-            <a:r>
-              <a:rPr sz="1300" b="0" i="0">
+              <a:rPr sz="1300" b="1" i="0">
                 <a:solidFill>
                   <a:srgbClr val="5A6472"/>
                 </a:solidFill>
                 <a:latin typeface="Segoe UI"/>
               </a:rPr>
-              <a:t>gated model vs its starting point — no detectable change</a:t>
-            </a:r>
-          </a:p>
-        </p:txBody>
-      </p:sp>
-      <p:sp>
-        <p:nvSpPr>
-          <p:cNvPr id="9" name="TextBox 8"/>
-          <p:cNvSpPr txBox="1"/>
-          <p:nvPr/>
-        </p:nvSpPr>
-        <p:spPr>
-          <a:xfrm>
-            <a:off x="685800" y="5943600"/>
-            <a:ext cx="10820095" cy="502920"/>
-          </a:xfrm>
-          <a:prstGeom prst="rect">
-            <a:avLst/>
-          </a:prstGeom>
-          <a:noFill/>
-        </p:spPr>
-        <p:txBody>
-          <a:bodyPr wrap="square">
-            <a:spAutoFit/>
-          </a:bodyPr>
-          <a:lstStyle/>
-          <a:p>
-            <a:pPr algn="l">
-              <a:spcBef>
-                <a:spcPts val="0"/>
-              </a:spcBef>
-              <a:spcAft>
-                <a:spcPts val="600"/>
-              </a:spcAft>
-            </a:pPr>
-            <a:r>
-              <a:rPr sz="1500" b="0" i="1">
+              <a:t>Results</a:t>
+            </a:r>
+          </a:p>
+          <a:p>
+            <a:pPr algn="l">
+              <a:spcBef>
+                <a:spcPts val="0"/>
+              </a:spcBef>
+              <a:spcAft>
+                <a:spcPts val="1200"/>
+              </a:spcAft>
+            </a:pPr>
+            <a:r>
+              <a:rPr sz="1200" b="0" i="0">
+                <a:solidFill>
+                  <a:srgbClr val="1A1D24"/>
+                </a:solidFill>
+                <a:latin typeface="Segoe UI"/>
+              </a:rPr>
+              <a:t>RESULTS.md — every number, reproducible</a:t>
+            </a:r>
+          </a:p>
+          <a:p>
+            <a:pPr algn="l">
+              <a:spcBef>
+                <a:spcPts val="0"/>
+              </a:spcBef>
+              <a:spcAft>
+                <a:spcPts val="200"/>
+              </a:spcAft>
+            </a:pPr>
+            <a:r>
+              <a:rPr sz="1300" b="1" i="0">
                 <a:solidFill>
                   <a:srgbClr val="5A6472"/>
                 </a:solidFill>
                 <a:latin typeface="Segoe UI"/>
               </a:rPr>
-              <a:t>v5 without the fixes: 31.2%. Gating converted a real regression into no change.</a:t>
+              <a:t>Demo</a:t>
+            </a:r>
+          </a:p>
+          <a:p>
+            <a:pPr algn="l">
+              <a:spcBef>
+                <a:spcPts val="0"/>
+              </a:spcBef>
+              <a:spcAft>
+                <a:spcPts val="0"/>
+              </a:spcAft>
+            </a:pPr>
+            <a:r>
+              <a:rPr sz="1200" b="0" i="0">
+                <a:solidFill>
+                  <a:srgbClr val="1A1D24"/>
+                </a:solidFill>
+                <a:latin typeface="Segoe UI"/>
+              </a:rPr>
+              <a:t>Live training dashboard + play any checkpoint</a:t>
             </a:r>
           </a:p>
         </p:txBody>

</xml_diff>

<commit_message>
Add dashboard screenshots to the README, and AlphaZero attribution
Screenshots: the repo front page showed no picture of the work. Adds the
dashboard and the browser demo, both captured headlessly from the running
UIs, directly under the title.

AlphaZero context: slide 1 and the video script now name DeepMind and the
2017 result, and state plainly that this reproduces that recipe at roughly
one millionth of the compute, so a reviewer can place the work. Slide 1's
footnote cites Silver et al., Science 2018 - already reference [1] in the
report.

Co-Authored-By: Claude Opus 5 <noreply@anthropic.com>
</commit_message>
<xml_diff>
--- a/docs/chess_ai_slides.pptx
+++ b/docs/chess_ai_slides.pptx
@@ -3240,13 +3240,32 @@
               </a:spcAft>
             </a:pPr>
             <a:r>
-              <a:rPr sz="1900" b="1" i="0">
+              <a:rPr sz="1700" b="1" i="0">
+                <a:solidFill>
+                  <a:srgbClr val="1F4E9C"/>
+                </a:solidFill>
+                <a:latin typeface="Segoe UI"/>
+              </a:rPr>
+              <a:t>Following AlphaZero — DeepMind, 2017</a:t>
+            </a:r>
+          </a:p>
+          <a:p>
+            <a:pPr algn="l">
+              <a:spcBef>
+                <a:spcPts val="0"/>
+              </a:spcBef>
+              <a:spcAft>
+                <a:spcPts val="1300"/>
+              </a:spcAft>
+            </a:pPr>
+            <a:r>
+              <a:rPr sz="1700" b="0" i="0">
                 <a:solidFill>
                   <a:srgbClr val="1A1D24"/>
                 </a:solidFill>
                 <a:latin typeface="Segoe UI"/>
               </a:rPr>
-              <a:t>No opening book. No piece values. No evaluation function.</a:t>
+              <a:t>DeepMind showed one network, trained only by playing itself, could master chess, shogi and Go and beat the strongest engines of the day.</a:t>
             </a:r>
           </a:p>
           <a:p>
@@ -3259,13 +3278,13 @@
               </a:spcAft>
             </a:pPr>
             <a:r>
-              <a:rPr sz="1900" b="0" i="0">
+              <a:rPr sz="1700" b="1" i="0">
                 <a:solidFill>
                   <a:srgbClr val="1A1D24"/>
                 </a:solidFill>
                 <a:latin typeface="Segoe UI"/>
               </a:rPr>
-              <a:t>Input: the rules, plus human games. Everything else is learned.</a:t>
+              <a:t>This project reproduces that recipe at ~1/1,000,000 the compute.</a:t>
             </a:r>
           </a:p>
           <a:p>
@@ -3278,13 +3297,13 @@
               </a:spcAft>
             </a:pPr>
             <a:r>
-              <a:rPr sz="1900" b="0" i="0">
+              <a:rPr sz="1700" b="0" i="0">
                 <a:solidFill>
                   <a:srgbClr val="1A1D24"/>
                 </a:solidFill>
                 <a:latin typeface="Segoe UI"/>
               </a:rPr>
-              <a:t>One network, two heads — policy (which moves look good) and value (who is winning).</a:t>
+              <a:t>No opening book, no piece values, no evaluation function — just the rules and data.</a:t>
             </a:r>
           </a:p>
           <a:p>
@@ -3297,32 +3316,13 @@
               </a:spcAft>
             </a:pPr>
             <a:r>
-              <a:rPr sz="1900" b="0" i="0">
+              <a:rPr sz="1700" b="0" i="0">
                 <a:solidFill>
                   <a:srgbClr val="1A1D24"/>
                 </a:solidFill>
                 <a:latin typeface="Segoe UI"/>
               </a:rPr>
-              <a:t>The network is not a player. Monte Carlo Tree Search turns it into one.</a:t>
-            </a:r>
-          </a:p>
-          <a:p>
-            <a:pPr algn="l">
-              <a:spcBef>
-                <a:spcPts val="0"/>
-              </a:spcBef>
-              <a:spcAft>
-                <a:spcPts val="1300"/>
-              </a:spcAft>
-            </a:pPr>
-            <a:r>
-              <a:rPr sz="1900" b="0" i="0">
-                <a:solidFill>
-                  <a:srgbClr val="1A1D24"/>
-                </a:solidFill>
-                <a:latin typeface="Segoe UI"/>
-              </a:rPr>
-              <a:t>Two stages: imitate humans, then improve by playing itself.</a:t>
+              <a:t>One network, two heads: policy (which moves look good) and value (who is winning). Monte Carlo Tree Search turns it into a player.</a:t>
             </a:r>
           </a:p>
         </p:txBody>
@@ -3574,7 +3574,7 @@
                 </a:solidFill>
                 <a:latin typeface="Segoe UI"/>
               </a:rPr>
-              <a:t>AlphaZero used ~5,000 TPUs. This runs on one desktop with an RTX 3060.</a:t>
+              <a:t>Silver et al., Science 2018. AlphaZero used ~5,000 TPUs; this runs on one desktop with an RTX 3060.</a:t>
             </a:r>
           </a:p>
         </p:txBody>

</xml_diff>